<commit_message>
ppt-studio finale: shadows, donut gauges, arc glyphs, cover diagrams, blueprint hero, thruBlk transitions
Co-authored-by: arena-agent <297053741+arena-agent@users.noreply.github.com>
</commit_message>
<xml_diff>
--- a/ppt-studio/build/CableTray_Redesign.pptx
+++ b/ppt-studio/build/CableTray_Redesign.pptx
@@ -4593,22 +4593,154 @@
       </p:sp>
       <p:sp>
         <p:nvSpPr>
-          <p:cNvPr id="4" name="Oval 3"/>
+          <p:cNvPr id="4" name="Rectangle 3"/>
           <p:cNvSpPr/>
           <p:nvPr/>
         </p:nvSpPr>
         <p:spPr>
           <a:xfrm>
-            <a:off x="10268712" y="1022299"/>
-            <a:ext cx="950976" cy="950976"/>
+            <a:off x="8229600" y="1325880"/>
+            <a:ext cx="146304" cy="1920240"/>
+          </a:xfrm>
+          <a:prstGeom prst="rect">
+            <a:avLst/>
+          </a:prstGeom>
+          <a:noFill/>
+          <a:ln w="22860">
+            <a:solidFill>
+              <a:srgbClr val="2E5073"/>
+            </a:solidFill>
+          </a:ln>
+          <a:effectLst/>
+        </p:spPr>
+        <p:style>
+          <a:lnRef idx="1">
+            <a:schemeClr val="accent1"/>
+          </a:lnRef>
+          <a:fillRef idx="3">
+            <a:schemeClr val="accent1"/>
+          </a:fillRef>
+          <a:effectRef idx="2">
+            <a:schemeClr val="accent1"/>
+          </a:effectRef>
+          <a:fontRef idx="minor">
+            <a:schemeClr val="lt1"/>
+          </a:fontRef>
+        </p:style>
+        <p:txBody>
+          <a:bodyPr rtlCol="0" anchor="ctr"/>
+          <a:lstStyle/>
+          <a:p>
+            <a:pPr algn="ctr"/>
+          </a:p>
+        </p:txBody>
+      </p:sp>
+      <p:sp>
+        <p:nvSpPr>
+          <p:cNvPr id="5" name="Rectangle 4"/>
+          <p:cNvSpPr/>
+          <p:nvPr/>
+        </p:nvSpPr>
+        <p:spPr>
+          <a:xfrm>
+            <a:off x="11100816" y="1325880"/>
+            <a:ext cx="146304" cy="1920240"/>
+          </a:xfrm>
+          <a:prstGeom prst="rect">
+            <a:avLst/>
+          </a:prstGeom>
+          <a:noFill/>
+          <a:ln w="22860">
+            <a:solidFill>
+              <a:srgbClr val="2E5073"/>
+            </a:solidFill>
+          </a:ln>
+          <a:effectLst/>
+        </p:spPr>
+        <p:style>
+          <a:lnRef idx="1">
+            <a:schemeClr val="accent1"/>
+          </a:lnRef>
+          <a:fillRef idx="3">
+            <a:schemeClr val="accent1"/>
+          </a:fillRef>
+          <a:effectRef idx="2">
+            <a:schemeClr val="accent1"/>
+          </a:effectRef>
+          <a:fontRef idx="minor">
+            <a:schemeClr val="lt1"/>
+          </a:fontRef>
+        </p:style>
+        <p:txBody>
+          <a:bodyPr rtlCol="0" anchor="ctr"/>
+          <a:lstStyle/>
+          <a:p>
+            <a:pPr algn="ctr"/>
+          </a:p>
+        </p:txBody>
+      </p:sp>
+      <p:sp>
+        <p:nvSpPr>
+          <p:cNvPr id="6" name="Rectangle 5"/>
+          <p:cNvSpPr/>
+          <p:nvPr/>
+        </p:nvSpPr>
+        <p:spPr>
+          <a:xfrm>
+            <a:off x="8229600" y="3081527"/>
+            <a:ext cx="3017520" cy="164592"/>
+          </a:xfrm>
+          <a:prstGeom prst="rect">
+            <a:avLst/>
+          </a:prstGeom>
+          <a:noFill/>
+          <a:ln w="22860">
+            <a:solidFill>
+              <a:srgbClr val="2E5073"/>
+            </a:solidFill>
+          </a:ln>
+          <a:effectLst/>
+        </p:spPr>
+        <p:style>
+          <a:lnRef idx="1">
+            <a:schemeClr val="accent1"/>
+          </a:lnRef>
+          <a:fillRef idx="3">
+            <a:schemeClr val="accent1"/>
+          </a:fillRef>
+          <a:effectRef idx="2">
+            <a:schemeClr val="accent1"/>
+          </a:effectRef>
+          <a:fontRef idx="minor">
+            <a:schemeClr val="lt1"/>
+          </a:fontRef>
+        </p:style>
+        <p:txBody>
+          <a:bodyPr rtlCol="0" anchor="ctr"/>
+          <a:lstStyle/>
+          <a:p>
+            <a:pPr algn="ctr"/>
+          </a:p>
+        </p:txBody>
+      </p:sp>
+      <p:sp>
+        <p:nvSpPr>
+          <p:cNvPr id="7" name="Oval 6"/>
+          <p:cNvSpPr/>
+          <p:nvPr/>
+        </p:nvSpPr>
+        <p:spPr>
+          <a:xfrm>
+            <a:off x="8787384" y="2284171"/>
+            <a:ext cx="310896" cy="310896"/>
           </a:xfrm>
           <a:prstGeom prst="ellipse">
             <a:avLst/>
           </a:prstGeom>
           <a:noFill/>
-          <a:ln w="20320">
+          <a:ln w="25400">
             <a:solidFill>
-              <a:srgbClr val="2A4A6B"/>
+              <a:srgbClr val="F5A623"/>
             </a:solidFill>
           </a:ln>
           <a:effectLst/>
@@ -4637,22 +4769,22 @@
       </p:sp>
       <p:sp>
         <p:nvSpPr>
-          <p:cNvPr id="5" name="Oval 4"/>
+          <p:cNvPr id="8" name="Oval 7"/>
           <p:cNvSpPr/>
           <p:nvPr/>
         </p:nvSpPr>
         <p:spPr>
           <a:xfrm>
-            <a:off x="9859792" y="1840138"/>
-            <a:ext cx="950976" cy="950976"/>
+            <a:off x="8653698" y="2551541"/>
+            <a:ext cx="310896" cy="310896"/>
           </a:xfrm>
           <a:prstGeom prst="ellipse">
             <a:avLst/>
           </a:prstGeom>
           <a:noFill/>
-          <a:ln w="20320">
+          <a:ln w="25400">
             <a:solidFill>
-              <a:srgbClr val="2A4A6B"/>
+              <a:srgbClr val="F5A623"/>
             </a:solidFill>
           </a:ln>
           <a:effectLst/>
@@ -4681,22 +4813,22 @@
       </p:sp>
       <p:sp>
         <p:nvSpPr>
-          <p:cNvPr id="6" name="Oval 5"/>
+          <p:cNvPr id="9" name="Oval 8"/>
           <p:cNvSpPr/>
           <p:nvPr/>
         </p:nvSpPr>
         <p:spPr>
           <a:xfrm>
-            <a:off x="10677631" y="1840138"/>
-            <a:ext cx="950976" cy="950976"/>
+            <a:off x="8921069" y="2551541"/>
+            <a:ext cx="310896" cy="310896"/>
           </a:xfrm>
           <a:prstGeom prst="ellipse">
             <a:avLst/>
           </a:prstGeom>
           <a:noFill/>
-          <a:ln w="20320">
+          <a:ln w="25400">
             <a:solidFill>
-              <a:srgbClr val="2A4A6B"/>
+              <a:srgbClr val="F5A623"/>
             </a:solidFill>
           </a:ln>
           <a:effectLst/>
@@ -4725,7 +4857,456 @@
       </p:sp>
       <p:sp>
         <p:nvSpPr>
-          <p:cNvPr id="7" name="Oval 6"/>
+          <p:cNvPr id="10" name="Oval 9"/>
+          <p:cNvSpPr/>
+          <p:nvPr/>
+        </p:nvSpPr>
+        <p:spPr>
+          <a:xfrm>
+            <a:off x="9646920" y="2284171"/>
+            <a:ext cx="310896" cy="310896"/>
+          </a:xfrm>
+          <a:prstGeom prst="ellipse">
+            <a:avLst/>
+          </a:prstGeom>
+          <a:noFill/>
+          <a:ln w="22860">
+            <a:solidFill>
+              <a:srgbClr val="2E5073"/>
+            </a:solidFill>
+          </a:ln>
+          <a:effectLst/>
+        </p:spPr>
+        <p:style>
+          <a:lnRef idx="1">
+            <a:schemeClr val="accent1"/>
+          </a:lnRef>
+          <a:fillRef idx="3">
+            <a:schemeClr val="accent1"/>
+          </a:fillRef>
+          <a:effectRef idx="2">
+            <a:schemeClr val="accent1"/>
+          </a:effectRef>
+          <a:fontRef idx="minor">
+            <a:schemeClr val="lt1"/>
+          </a:fontRef>
+        </p:style>
+        <p:txBody>
+          <a:bodyPr rtlCol="0" anchor="ctr"/>
+          <a:lstStyle/>
+          <a:p>
+            <a:pPr algn="ctr"/>
+          </a:p>
+        </p:txBody>
+      </p:sp>
+      <p:sp>
+        <p:nvSpPr>
+          <p:cNvPr id="11" name="Oval 10"/>
+          <p:cNvSpPr/>
+          <p:nvPr/>
+        </p:nvSpPr>
+        <p:spPr>
+          <a:xfrm>
+            <a:off x="9513234" y="2551541"/>
+            <a:ext cx="310896" cy="310896"/>
+          </a:xfrm>
+          <a:prstGeom prst="ellipse">
+            <a:avLst/>
+          </a:prstGeom>
+          <a:noFill/>
+          <a:ln w="22860">
+            <a:solidFill>
+              <a:srgbClr val="2E5073"/>
+            </a:solidFill>
+          </a:ln>
+          <a:effectLst/>
+        </p:spPr>
+        <p:style>
+          <a:lnRef idx="1">
+            <a:schemeClr val="accent1"/>
+          </a:lnRef>
+          <a:fillRef idx="3">
+            <a:schemeClr val="accent1"/>
+          </a:fillRef>
+          <a:effectRef idx="2">
+            <a:schemeClr val="accent1"/>
+          </a:effectRef>
+          <a:fontRef idx="minor">
+            <a:schemeClr val="lt1"/>
+          </a:fontRef>
+        </p:style>
+        <p:txBody>
+          <a:bodyPr rtlCol="0" anchor="ctr"/>
+          <a:lstStyle/>
+          <a:p>
+            <a:pPr algn="ctr"/>
+          </a:p>
+        </p:txBody>
+      </p:sp>
+      <p:sp>
+        <p:nvSpPr>
+          <p:cNvPr id="12" name="Oval 11"/>
+          <p:cNvSpPr/>
+          <p:nvPr/>
+        </p:nvSpPr>
+        <p:spPr>
+          <a:xfrm>
+            <a:off x="9780605" y="2551541"/>
+            <a:ext cx="310896" cy="310896"/>
+          </a:xfrm>
+          <a:prstGeom prst="ellipse">
+            <a:avLst/>
+          </a:prstGeom>
+          <a:noFill/>
+          <a:ln w="22860">
+            <a:solidFill>
+              <a:srgbClr val="2E5073"/>
+            </a:solidFill>
+          </a:ln>
+          <a:effectLst/>
+        </p:spPr>
+        <p:style>
+          <a:lnRef idx="1">
+            <a:schemeClr val="accent1"/>
+          </a:lnRef>
+          <a:fillRef idx="3">
+            <a:schemeClr val="accent1"/>
+          </a:fillRef>
+          <a:effectRef idx="2">
+            <a:schemeClr val="accent1"/>
+          </a:effectRef>
+          <a:fontRef idx="minor">
+            <a:schemeClr val="lt1"/>
+          </a:fontRef>
+        </p:style>
+        <p:txBody>
+          <a:bodyPr rtlCol="0" anchor="ctr"/>
+          <a:lstStyle/>
+          <a:p>
+            <a:pPr algn="ctr"/>
+          </a:p>
+        </p:txBody>
+      </p:sp>
+      <p:sp>
+        <p:nvSpPr>
+          <p:cNvPr id="13" name="Oval 12"/>
+          <p:cNvSpPr/>
+          <p:nvPr/>
+        </p:nvSpPr>
+        <p:spPr>
+          <a:xfrm>
+            <a:off x="10442448" y="2770632"/>
+            <a:ext cx="219456" cy="219456"/>
+          </a:xfrm>
+          <a:prstGeom prst="ellipse">
+            <a:avLst/>
+          </a:prstGeom>
+          <a:noFill/>
+          <a:ln w="22860">
+            <a:solidFill>
+              <a:srgbClr val="2E5073"/>
+            </a:solidFill>
+          </a:ln>
+          <a:effectLst/>
+        </p:spPr>
+        <p:style>
+          <a:lnRef idx="1">
+            <a:schemeClr val="accent1"/>
+          </a:lnRef>
+          <a:fillRef idx="3">
+            <a:schemeClr val="accent1"/>
+          </a:fillRef>
+          <a:effectRef idx="2">
+            <a:schemeClr val="accent1"/>
+          </a:effectRef>
+          <a:fontRef idx="minor">
+            <a:schemeClr val="lt1"/>
+          </a:fontRef>
+        </p:style>
+        <p:txBody>
+          <a:bodyPr rtlCol="0" anchor="ctr"/>
+          <a:lstStyle/>
+          <a:p>
+            <a:pPr algn="ctr"/>
+          </a:p>
+        </p:txBody>
+      </p:sp>
+      <p:sp>
+        <p:nvSpPr>
+          <p:cNvPr id="14" name="Oval 13"/>
+          <p:cNvSpPr/>
+          <p:nvPr/>
+        </p:nvSpPr>
+        <p:spPr>
+          <a:xfrm>
+            <a:off x="10680192" y="2770632"/>
+            <a:ext cx="219456" cy="219456"/>
+          </a:xfrm>
+          <a:prstGeom prst="ellipse">
+            <a:avLst/>
+          </a:prstGeom>
+          <a:noFill/>
+          <a:ln w="22860">
+            <a:solidFill>
+              <a:srgbClr val="2E5073"/>
+            </a:solidFill>
+          </a:ln>
+          <a:effectLst/>
+        </p:spPr>
+        <p:style>
+          <a:lnRef idx="1">
+            <a:schemeClr val="accent1"/>
+          </a:lnRef>
+          <a:fillRef idx="3">
+            <a:schemeClr val="accent1"/>
+          </a:fillRef>
+          <a:effectRef idx="2">
+            <a:schemeClr val="accent1"/>
+          </a:effectRef>
+          <a:fontRef idx="minor">
+            <a:schemeClr val="lt1"/>
+          </a:fontRef>
+        </p:style>
+        <p:txBody>
+          <a:bodyPr rtlCol="0" anchor="ctr"/>
+          <a:lstStyle/>
+          <a:p>
+            <a:pPr algn="ctr"/>
+          </a:p>
+        </p:txBody>
+      </p:sp>
+      <p:sp>
+        <p:nvSpPr>
+          <p:cNvPr id="15" name="Oval 14"/>
+          <p:cNvSpPr/>
+          <p:nvPr/>
+        </p:nvSpPr>
+        <p:spPr>
+          <a:xfrm>
+            <a:off x="10917936" y="2770632"/>
+            <a:ext cx="219456" cy="219456"/>
+          </a:xfrm>
+          <a:prstGeom prst="ellipse">
+            <a:avLst/>
+          </a:prstGeom>
+          <a:noFill/>
+          <a:ln w="22860">
+            <a:solidFill>
+              <a:srgbClr val="2E5073"/>
+            </a:solidFill>
+          </a:ln>
+          <a:effectLst/>
+        </p:spPr>
+        <p:style>
+          <a:lnRef idx="1">
+            <a:schemeClr val="accent1"/>
+          </a:lnRef>
+          <a:fillRef idx="3">
+            <a:schemeClr val="accent1"/>
+          </a:fillRef>
+          <a:effectRef idx="2">
+            <a:schemeClr val="accent1"/>
+          </a:effectRef>
+          <a:fontRef idx="minor">
+            <a:schemeClr val="lt1"/>
+          </a:fontRef>
+        </p:style>
+        <p:txBody>
+          <a:bodyPr rtlCol="0" anchor="ctr"/>
+          <a:lstStyle/>
+          <a:p>
+            <a:pPr algn="ctr"/>
+          </a:p>
+        </p:txBody>
+      </p:sp>
+      <p:cxnSp>
+        <p:nvCxnSpPr>
+          <p:cNvPr id="16" name="Connector 15"/>
+          <p:cNvCxnSpPr/>
+          <p:nvPr/>
+        </p:nvCxnSpPr>
+        <p:spPr>
+          <a:xfrm>
+            <a:off x="8229600" y="1033271"/>
+            <a:ext cx="3017520" cy="0"/>
+          </a:xfrm>
+          <a:prstGeom prst="line">
+            <a:avLst/>
+          </a:prstGeom>
+          <a:ln w="15240">
+            <a:solidFill>
+              <a:srgbClr val="244466"/>
+            </a:solidFill>
+          </a:ln>
+          <a:effectLst/>
+        </p:spPr>
+        <p:style>
+          <a:lnRef idx="2">
+            <a:schemeClr val="accent1"/>
+          </a:lnRef>
+          <a:fillRef idx="0">
+            <a:schemeClr val="accent1"/>
+          </a:fillRef>
+          <a:effectRef idx="1">
+            <a:schemeClr val="accent1"/>
+          </a:effectRef>
+          <a:fontRef idx="minor">
+            <a:schemeClr val="tx1"/>
+          </a:fontRef>
+        </p:style>
+      </p:cxnSp>
+      <p:cxnSp>
+        <p:nvCxnSpPr>
+          <p:cNvPr id="17" name="Connector 16"/>
+          <p:cNvCxnSpPr/>
+          <p:nvPr/>
+        </p:nvCxnSpPr>
+        <p:spPr>
+          <a:xfrm>
+            <a:off x="8229600" y="941832"/>
+            <a:ext cx="0" cy="182880"/>
+          </a:xfrm>
+          <a:prstGeom prst="line">
+            <a:avLst/>
+          </a:prstGeom>
+          <a:ln w="15240">
+            <a:solidFill>
+              <a:srgbClr val="244466"/>
+            </a:solidFill>
+          </a:ln>
+          <a:effectLst/>
+        </p:spPr>
+        <p:style>
+          <a:lnRef idx="2">
+            <a:schemeClr val="accent1"/>
+          </a:lnRef>
+          <a:fillRef idx="0">
+            <a:schemeClr val="accent1"/>
+          </a:fillRef>
+          <a:effectRef idx="1">
+            <a:schemeClr val="accent1"/>
+          </a:effectRef>
+          <a:fontRef idx="minor">
+            <a:schemeClr val="tx1"/>
+          </a:fontRef>
+        </p:style>
+      </p:cxnSp>
+      <p:cxnSp>
+        <p:nvCxnSpPr>
+          <p:cNvPr id="18" name="Connector 17"/>
+          <p:cNvCxnSpPr/>
+          <p:nvPr/>
+        </p:nvCxnSpPr>
+        <p:spPr>
+          <a:xfrm>
+            <a:off x="11247120" y="941832"/>
+            <a:ext cx="0" cy="182880"/>
+          </a:xfrm>
+          <a:prstGeom prst="line">
+            <a:avLst/>
+          </a:prstGeom>
+          <a:ln w="15240">
+            <a:solidFill>
+              <a:srgbClr val="244466"/>
+            </a:solidFill>
+          </a:ln>
+          <a:effectLst/>
+        </p:spPr>
+        <p:style>
+          <a:lnRef idx="2">
+            <a:schemeClr val="accent1"/>
+          </a:lnRef>
+          <a:fillRef idx="0">
+            <a:schemeClr val="accent1"/>
+          </a:fillRef>
+          <a:effectRef idx="1">
+            <a:schemeClr val="accent1"/>
+          </a:effectRef>
+          <a:fontRef idx="minor">
+            <a:schemeClr val="tx1"/>
+          </a:fontRef>
+        </p:style>
+      </p:cxnSp>
+      <p:sp>
+        <p:nvSpPr>
+          <p:cNvPr id="19" name="TextBox 18"/>
+          <p:cNvSpPr txBox="1"/>
+          <p:nvPr/>
+        </p:nvSpPr>
+        <p:spPr>
+          <a:xfrm>
+            <a:off x="8229600" y="704087"/>
+            <a:ext cx="3017520" cy="274320"/>
+          </a:xfrm>
+          <a:prstGeom prst="rect">
+            <a:avLst/>
+          </a:prstGeom>
+          <a:noFill/>
+        </p:spPr>
+        <p:txBody>
+          <a:bodyPr wrap="square" anchor="t" lIns="0" rIns="0" tIns="0" bIns="0">
+            <a:spAutoFit/>
+          </a:bodyPr>
+          <a:lstStyle/>
+          <a:p>
+            <a:pPr algn="ctr">
+              <a:lnSpc>
+                <a:spcPct val="100000"/>
+              </a:lnSpc>
+            </a:pPr>
+            <a:r>
+              <a:rPr sz="1100" b="1">
+                <a:solidFill>
+                  <a:srgbClr val="2E5073"/>
+                </a:solidFill>
+                <a:latin typeface="Calibri"/>
+                <a:ea typeface="Calibri"/>
+              </a:rPr>
+              <a:t>W</a:t>
+            </a:r>
+          </a:p>
+        </p:txBody>
+      </p:sp>
+      <p:cxnSp>
+        <p:nvCxnSpPr>
+          <p:cNvPr id="20" name="Connector 19"/>
+          <p:cNvCxnSpPr/>
+          <p:nvPr/>
+        </p:nvCxnSpPr>
+        <p:spPr>
+          <a:xfrm>
+            <a:off x="7955279" y="3566160"/>
+            <a:ext cx="3566161" cy="0"/>
+          </a:xfrm>
+          <a:prstGeom prst="line">
+            <a:avLst/>
+          </a:prstGeom>
+          <a:ln w="12700">
+            <a:solidFill>
+              <a:srgbClr val="244466"/>
+            </a:solidFill>
+            <a:prstDash val="dash"/>
+          </a:ln>
+          <a:effectLst/>
+        </p:spPr>
+        <p:style>
+          <a:lnRef idx="2">
+            <a:schemeClr val="accent1"/>
+          </a:lnRef>
+          <a:fillRef idx="0">
+            <a:schemeClr val="accent1"/>
+          </a:fillRef>
+          <a:effectRef idx="1">
+            <a:schemeClr val="accent1"/>
+          </a:effectRef>
+          <a:fontRef idx="minor">
+            <a:schemeClr val="tx1"/>
+          </a:fontRef>
+        </p:style>
+      </p:cxnSp>
+      <p:sp>
+        <p:nvSpPr>
+          <p:cNvPr id="21" name="Oval 20"/>
           <p:cNvSpPr/>
           <p:nvPr/>
         </p:nvSpPr>
@@ -4769,7 +5350,7 @@
       </p:sp>
       <p:sp>
         <p:nvSpPr>
-          <p:cNvPr id="8" name="Rectangle 7"/>
+          <p:cNvPr id="22" name="Rectangle 21"/>
           <p:cNvSpPr/>
           <p:nvPr/>
         </p:nvSpPr>
@@ -4813,7 +5394,7 @@
       </p:sp>
       <p:cxnSp>
         <p:nvCxnSpPr>
-          <p:cNvPr id="9" name="Connector 8"/>
+          <p:cNvPr id="23" name="Connector 22"/>
           <p:cNvCxnSpPr/>
           <p:nvPr/>
         </p:nvCxnSpPr>
@@ -4849,7 +5430,7 @@
       </p:cxnSp>
       <p:sp>
         <p:nvSpPr>
-          <p:cNvPr id="10" name="TextBox 9"/>
+          <p:cNvPr id="24" name="TextBox 23"/>
           <p:cNvSpPr txBox="1"/>
           <p:nvPr/>
         </p:nvSpPr>
@@ -4889,7 +5470,7 @@
       </p:sp>
       <p:sp>
         <p:nvSpPr>
-          <p:cNvPr id="11" name="TextBox 10"/>
+          <p:cNvPr id="25" name="TextBox 24"/>
           <p:cNvSpPr txBox="1"/>
           <p:nvPr/>
         </p:nvSpPr>
@@ -4946,7 +5527,7 @@
       </p:sp>
       <p:sp>
         <p:nvSpPr>
-          <p:cNvPr id="12" name="TextBox 11"/>
+          <p:cNvPr id="26" name="TextBox 25"/>
           <p:cNvSpPr txBox="1"/>
           <p:nvPr/>
         </p:nvSpPr>
@@ -4986,7 +5567,7 @@
       </p:sp>
       <p:sp>
         <p:nvSpPr>
-          <p:cNvPr id="13" name="Rounded Rectangle 12"/>
+          <p:cNvPr id="27" name="Rounded Rectangle 26"/>
           <p:cNvSpPr/>
           <p:nvPr/>
         </p:nvSpPr>
@@ -5032,7 +5613,7 @@
       </p:sp>
       <p:sp>
         <p:nvSpPr>
-          <p:cNvPr id="14" name="TextBox 13"/>
+          <p:cNvPr id="28" name="TextBox 27"/>
           <p:cNvSpPr txBox="1"/>
           <p:nvPr/>
         </p:nvSpPr>
@@ -5072,7 +5653,7 @@
       </p:sp>
       <p:sp>
         <p:nvSpPr>
-          <p:cNvPr id="15" name="Rounded Rectangle 14"/>
+          <p:cNvPr id="29" name="Rounded Rectangle 28"/>
           <p:cNvSpPr/>
           <p:nvPr/>
         </p:nvSpPr>
@@ -5118,7 +5699,7 @@
       </p:sp>
       <p:sp>
         <p:nvSpPr>
-          <p:cNvPr id="16" name="TextBox 15"/>
+          <p:cNvPr id="30" name="TextBox 29"/>
           <p:cNvSpPr txBox="1"/>
           <p:nvPr/>
         </p:nvSpPr>
@@ -5158,7 +5739,7 @@
       </p:sp>
       <p:sp>
         <p:nvSpPr>
-          <p:cNvPr id="17" name="Rounded Rectangle 16"/>
+          <p:cNvPr id="31" name="Rounded Rectangle 30"/>
           <p:cNvSpPr/>
           <p:nvPr/>
         </p:nvSpPr>
@@ -5204,7 +5785,7 @@
       </p:sp>
       <p:sp>
         <p:nvSpPr>
-          <p:cNvPr id="18" name="TextBox 17"/>
+          <p:cNvPr id="32" name="TextBox 31"/>
           <p:cNvSpPr txBox="1"/>
           <p:nvPr/>
         </p:nvSpPr>
@@ -5244,7 +5825,7 @@
       </p:sp>
       <p:sp>
         <p:nvSpPr>
-          <p:cNvPr id="19" name="Rounded Rectangle 18"/>
+          <p:cNvPr id="33" name="Rounded Rectangle 32"/>
           <p:cNvSpPr/>
           <p:nvPr/>
         </p:nvSpPr>
@@ -5290,7 +5871,7 @@
       </p:sp>
       <p:sp>
         <p:nvSpPr>
-          <p:cNvPr id="20" name="TextBox 19"/>
+          <p:cNvPr id="34" name="TextBox 33"/>
           <p:cNvSpPr txBox="1"/>
           <p:nvPr/>
         </p:nvSpPr>
@@ -5330,7 +5911,7 @@
       </p:sp>
       <p:sp>
         <p:nvSpPr>
-          <p:cNvPr id="21" name="Rounded Rectangle 20"/>
+          <p:cNvPr id="35" name="Rounded Rectangle 34"/>
           <p:cNvSpPr/>
           <p:nvPr/>
         </p:nvSpPr>
@@ -5376,7 +5957,7 @@
       </p:sp>
       <p:sp>
         <p:nvSpPr>
-          <p:cNvPr id="22" name="TextBox 21"/>
+          <p:cNvPr id="36" name="TextBox 35"/>
           <p:cNvSpPr txBox="1"/>
           <p:nvPr/>
         </p:nvSpPr>
@@ -5416,7 +5997,7 @@
       </p:sp>
       <p:cxnSp>
         <p:nvCxnSpPr>
-          <p:cNvPr id="23" name="Connector 22"/>
+          <p:cNvPr id="37" name="Connector 36"/>
           <p:cNvCxnSpPr/>
           <p:nvPr/>
         </p:nvCxnSpPr>
@@ -5452,7 +6033,7 @@
       </p:cxnSp>
       <p:sp>
         <p:nvSpPr>
-          <p:cNvPr id="24" name="TextBox 23"/>
+          <p:cNvPr id="38" name="TextBox 37"/>
           <p:cNvSpPr txBox="1"/>
           <p:nvPr/>
         </p:nvSpPr>
@@ -5506,7 +6087,7 @@
     <a:masterClrMapping/>
   </p:clrMapOvr>
   <p:transition spd="med">
-    <p:fade/>
+    <p:fade thruBlk="1"/>
   </p:transition>
 </p:sld>
 </file>
@@ -6079,7 +6660,13 @@
               <a:srgbClr val="D9E2EC"/>
             </a:solidFill>
           </a:ln>
-          <a:effectLst/>
+          <a:effectLst>
+            <a:outerShdw blurRad="140000" dist="50000" dir="5400000" rotWithShape="0">
+              <a:srgbClr val="16314E">
+                <a:alpha val="15000"/>
+              </a:srgbClr>
+            </a:outerShdw>
+          </a:effectLst>
         </p:spPr>
         <p:style>
           <a:lnRef idx="1">
@@ -6149,16 +6736,60 @@
       </p:sp>
       <p:sp>
         <p:nvSpPr>
-          <p:cNvPr id="17" name="Oval 16"/>
+          <p:cNvPr id="17" name="Rectangle 16"/>
           <p:cNvSpPr/>
           <p:nvPr/>
         </p:nvSpPr>
         <p:spPr>
           <a:xfrm>
-            <a:off x="822960" y="2029968"/>
-            <a:ext cx="420624" cy="420624"/>
-          </a:xfrm>
-          <a:prstGeom prst="ellipse">
+            <a:off x="822960" y="2340864"/>
+            <a:ext cx="914400" cy="91440"/>
+          </a:xfrm>
+          <a:prstGeom prst="rect">
+            <a:avLst/>
+          </a:prstGeom>
+          <a:solidFill>
+            <a:srgbClr val="C9D6E2"/>
+          </a:solidFill>
+          <a:ln>
+            <a:noFill/>
+          </a:ln>
+          <a:effectLst/>
+        </p:spPr>
+        <p:style>
+          <a:lnRef idx="1">
+            <a:schemeClr val="accent1"/>
+          </a:lnRef>
+          <a:fillRef idx="3">
+            <a:schemeClr val="accent1"/>
+          </a:fillRef>
+          <a:effectRef idx="2">
+            <a:schemeClr val="accent1"/>
+          </a:effectRef>
+          <a:fontRef idx="minor">
+            <a:schemeClr val="lt1"/>
+          </a:fontRef>
+        </p:style>
+        <p:txBody>
+          <a:bodyPr rtlCol="0" anchor="ctr"/>
+          <a:lstStyle/>
+          <a:p>
+            <a:pPr algn="ctr"/>
+          </a:p>
+        </p:txBody>
+      </p:sp>
+      <p:sp>
+        <p:nvSpPr>
+          <p:cNvPr id="18" name="Isosceles Triangle 17"/>
+          <p:cNvSpPr/>
+          <p:nvPr/>
+        </p:nvSpPr>
+        <p:spPr>
+          <a:xfrm>
+            <a:off x="768096" y="2103120"/>
+            <a:ext cx="1024128" cy="219456"/>
+          </a:xfrm>
+          <a:prstGeom prst="triangle">
             <a:avLst/>
           </a:prstGeom>
           <a:solidFill>
@@ -6188,46 +6819,6 @@
           <a:lstStyle/>
           <a:p>
             <a:pPr algn="ctr"/>
-          </a:p>
-        </p:txBody>
-      </p:sp>
-      <p:sp>
-        <p:nvSpPr>
-          <p:cNvPr id="18" name="TextBox 17"/>
-          <p:cNvSpPr txBox="1"/>
-          <p:nvPr/>
-        </p:nvSpPr>
-        <p:spPr>
-          <a:xfrm>
-            <a:off x="822960" y="2018995"/>
-            <a:ext cx="420624" cy="420624"/>
-          </a:xfrm>
-          <a:prstGeom prst="rect">
-            <a:avLst/>
-          </a:prstGeom>
-          <a:noFill/>
-        </p:spPr>
-        <p:txBody>
-          <a:bodyPr wrap="square" anchor="ctr" lIns="0" rIns="0" tIns="0" bIns="0">
-            <a:spAutoFit/>
-          </a:bodyPr>
-          <a:lstStyle/>
-          <a:p>
-            <a:pPr algn="ctr">
-              <a:lnSpc>
-                <a:spcPct val="100000"/>
-              </a:lnSpc>
-            </a:pPr>
-            <a:r>
-              <a:rPr sz="1250" b="1">
-                <a:solidFill>
-                  <a:srgbClr val="FFFFFF"/>
-                </a:solidFill>
-                <a:latin typeface="Calibri"/>
-                <a:ea typeface="Calibri"/>
-              </a:rPr>
-              <a:t>01</a:t>
-            </a:r>
           </a:p>
         </p:txBody>
       </p:sp>
@@ -6421,7 +7012,13 @@
               <a:srgbClr val="D9E2EC"/>
             </a:solidFill>
           </a:ln>
-          <a:effectLst/>
+          <a:effectLst>
+            <a:outerShdw blurRad="140000" dist="50000" dir="5400000" rotWithShape="0">
+              <a:srgbClr val="16314E">
+                <a:alpha val="15000"/>
+              </a:srgbClr>
+            </a:outerShdw>
+          </a:effectLst>
         </p:spPr>
         <p:style>
           <a:lnRef idx="1">
@@ -6491,16 +7088,60 @@
       </p:sp>
       <p:sp>
         <p:nvSpPr>
-          <p:cNvPr id="25" name="Oval 24"/>
+          <p:cNvPr id="25" name="Rectangle 24"/>
           <p:cNvSpPr/>
           <p:nvPr/>
         </p:nvSpPr>
         <p:spPr>
           <a:xfrm>
-            <a:off x="3646855" y="2029968"/>
-            <a:ext cx="420624" cy="420624"/>
-          </a:xfrm>
-          <a:prstGeom prst="ellipse">
+            <a:off x="3646855" y="2340864"/>
+            <a:ext cx="914400" cy="91440"/>
+          </a:xfrm>
+          <a:prstGeom prst="rect">
+            <a:avLst/>
+          </a:prstGeom>
+          <a:solidFill>
+            <a:srgbClr val="C9D6E2"/>
+          </a:solidFill>
+          <a:ln>
+            <a:noFill/>
+          </a:ln>
+          <a:effectLst/>
+        </p:spPr>
+        <p:style>
+          <a:lnRef idx="1">
+            <a:schemeClr val="accent1"/>
+          </a:lnRef>
+          <a:fillRef idx="3">
+            <a:schemeClr val="accent1"/>
+          </a:fillRef>
+          <a:effectRef idx="2">
+            <a:schemeClr val="accent1"/>
+          </a:effectRef>
+          <a:fontRef idx="minor">
+            <a:schemeClr val="lt1"/>
+          </a:fontRef>
+        </p:style>
+        <p:txBody>
+          <a:bodyPr rtlCol="0" anchor="ctr"/>
+          <a:lstStyle/>
+          <a:p>
+            <a:pPr algn="ctr"/>
+          </a:p>
+        </p:txBody>
+      </p:sp>
+      <p:sp>
+        <p:nvSpPr>
+          <p:cNvPr id="26" name="Rectangle 25"/>
+          <p:cNvSpPr/>
+          <p:nvPr/>
+        </p:nvSpPr>
+        <p:spPr>
+          <a:xfrm>
+            <a:off x="3591991" y="2176272"/>
+            <a:ext cx="1024128" cy="91440"/>
+          </a:xfrm>
+          <a:prstGeom prst="rect">
             <a:avLst/>
           </a:prstGeom>
           <a:solidFill>
@@ -6530,46 +7171,6 @@
           <a:lstStyle/>
           <a:p>
             <a:pPr algn="ctr"/>
-          </a:p>
-        </p:txBody>
-      </p:sp>
-      <p:sp>
-        <p:nvSpPr>
-          <p:cNvPr id="26" name="TextBox 25"/>
-          <p:cNvSpPr txBox="1"/>
-          <p:nvPr/>
-        </p:nvSpPr>
-        <p:spPr>
-          <a:xfrm>
-            <a:off x="3646855" y="2018995"/>
-            <a:ext cx="420624" cy="420624"/>
-          </a:xfrm>
-          <a:prstGeom prst="rect">
-            <a:avLst/>
-          </a:prstGeom>
-          <a:noFill/>
-        </p:spPr>
-        <p:txBody>
-          <a:bodyPr wrap="square" anchor="ctr" lIns="0" rIns="0" tIns="0" bIns="0">
-            <a:spAutoFit/>
-          </a:bodyPr>
-          <a:lstStyle/>
-          <a:p>
-            <a:pPr algn="ctr">
-              <a:lnSpc>
-                <a:spcPct val="100000"/>
-              </a:lnSpc>
-            </a:pPr>
-            <a:r>
-              <a:rPr sz="1250" b="1">
-                <a:solidFill>
-                  <a:srgbClr val="FFFFFF"/>
-                </a:solidFill>
-                <a:latin typeface="Calibri"/>
-                <a:ea typeface="Calibri"/>
-              </a:rPr>
-              <a:t>02</a:t>
-            </a:r>
           </a:p>
         </p:txBody>
       </p:sp>
@@ -6763,7 +7364,13 @@
               <a:srgbClr val="D9E2EC"/>
             </a:solidFill>
           </a:ln>
-          <a:effectLst/>
+          <a:effectLst>
+            <a:outerShdw blurRad="140000" dist="50000" dir="5400000" rotWithShape="0">
+              <a:srgbClr val="16314E">
+                <a:alpha val="15000"/>
+              </a:srgbClr>
+            </a:outerShdw>
+          </a:effectLst>
         </p:spPr>
         <p:style>
           <a:lnRef idx="1">
@@ -6833,16 +7440,60 @@
       </p:sp>
       <p:sp>
         <p:nvSpPr>
-          <p:cNvPr id="33" name="Oval 32"/>
+          <p:cNvPr id="33" name="Rectangle 32"/>
           <p:cNvSpPr/>
           <p:nvPr/>
         </p:nvSpPr>
         <p:spPr>
           <a:xfrm>
-            <a:off x="6470751" y="2029968"/>
-            <a:ext cx="420624" cy="420624"/>
-          </a:xfrm>
-          <a:prstGeom prst="ellipse">
+            <a:off x="6470751" y="2340864"/>
+            <a:ext cx="914400" cy="91440"/>
+          </a:xfrm>
+          <a:prstGeom prst="rect">
+            <a:avLst/>
+          </a:prstGeom>
+          <a:solidFill>
+            <a:srgbClr val="C9D6E2"/>
+          </a:solidFill>
+          <a:ln>
+            <a:noFill/>
+          </a:ln>
+          <a:effectLst/>
+        </p:spPr>
+        <p:style>
+          <a:lnRef idx="1">
+            <a:schemeClr val="accent1"/>
+          </a:lnRef>
+          <a:fillRef idx="3">
+            <a:schemeClr val="accent1"/>
+          </a:fillRef>
+          <a:effectRef idx="2">
+            <a:schemeClr val="accent1"/>
+          </a:effectRef>
+          <a:fontRef idx="minor">
+            <a:schemeClr val="lt1"/>
+          </a:fontRef>
+        </p:style>
+        <p:txBody>
+          <a:bodyPr rtlCol="0" anchor="ctr"/>
+          <a:lstStyle/>
+          <a:p>
+            <a:pPr algn="ctr"/>
+          </a:p>
+        </p:txBody>
+      </p:sp>
+      <p:sp>
+        <p:nvSpPr>
+          <p:cNvPr id="34" name="Down Arrow 33"/>
+          <p:cNvSpPr/>
+          <p:nvPr/>
+        </p:nvSpPr>
+        <p:spPr>
+          <a:xfrm>
+            <a:off x="6827367" y="2029968"/>
+            <a:ext cx="201168" cy="274320"/>
+          </a:xfrm>
+          <a:prstGeom prst="downArrow">
             <a:avLst/>
           </a:prstGeom>
           <a:solidFill>
@@ -6872,46 +7523,6 @@
           <a:lstStyle/>
           <a:p>
             <a:pPr algn="ctr"/>
-          </a:p>
-        </p:txBody>
-      </p:sp>
-      <p:sp>
-        <p:nvSpPr>
-          <p:cNvPr id="34" name="TextBox 33"/>
-          <p:cNvSpPr txBox="1"/>
-          <p:nvPr/>
-        </p:nvSpPr>
-        <p:spPr>
-          <a:xfrm>
-            <a:off x="6470751" y="2018995"/>
-            <a:ext cx="420624" cy="420624"/>
-          </a:xfrm>
-          <a:prstGeom prst="rect">
-            <a:avLst/>
-          </a:prstGeom>
-          <a:noFill/>
-        </p:spPr>
-        <p:txBody>
-          <a:bodyPr wrap="square" anchor="ctr" lIns="0" rIns="0" tIns="0" bIns="0">
-            <a:spAutoFit/>
-          </a:bodyPr>
-          <a:lstStyle/>
-          <a:p>
-            <a:pPr algn="ctr">
-              <a:lnSpc>
-                <a:spcPct val="100000"/>
-              </a:lnSpc>
-            </a:pPr>
-            <a:r>
-              <a:rPr sz="1250" b="1">
-                <a:solidFill>
-                  <a:srgbClr val="FFFFFF"/>
-                </a:solidFill>
-                <a:latin typeface="Calibri"/>
-                <a:ea typeface="Calibri"/>
-              </a:rPr>
-              <a:t>03</a:t>
-            </a:r>
           </a:p>
         </p:txBody>
       </p:sp>
@@ -7105,7 +7716,13 @@
               <a:srgbClr val="D9E2EC"/>
             </a:solidFill>
           </a:ln>
-          <a:effectLst/>
+          <a:effectLst>
+            <a:outerShdw blurRad="140000" dist="50000" dir="5400000" rotWithShape="0">
+              <a:srgbClr val="16314E">
+                <a:alpha val="15000"/>
+              </a:srgbClr>
+            </a:outerShdw>
+          </a:effectLst>
         </p:spPr>
         <p:style>
           <a:lnRef idx="1">
@@ -7175,16 +7792,60 @@
       </p:sp>
       <p:sp>
         <p:nvSpPr>
-          <p:cNvPr id="41" name="Oval 40"/>
+          <p:cNvPr id="41" name="Rectangle 40"/>
           <p:cNvSpPr/>
           <p:nvPr/>
         </p:nvSpPr>
         <p:spPr>
           <a:xfrm>
-            <a:off x="9294647" y="2029968"/>
-            <a:ext cx="420624" cy="420624"/>
-          </a:xfrm>
-          <a:prstGeom prst="ellipse">
+            <a:off x="9294647" y="2340864"/>
+            <a:ext cx="914400" cy="91440"/>
+          </a:xfrm>
+          <a:prstGeom prst="rect">
+            <a:avLst/>
+          </a:prstGeom>
+          <a:solidFill>
+            <a:srgbClr val="C9D6E2"/>
+          </a:solidFill>
+          <a:ln>
+            <a:noFill/>
+          </a:ln>
+          <a:effectLst/>
+        </p:spPr>
+        <p:style>
+          <a:lnRef idx="1">
+            <a:schemeClr val="accent1"/>
+          </a:lnRef>
+          <a:fillRef idx="3">
+            <a:schemeClr val="accent1"/>
+          </a:fillRef>
+          <a:effectRef idx="2">
+            <a:schemeClr val="accent1"/>
+          </a:effectRef>
+          <a:fontRef idx="minor">
+            <a:schemeClr val="lt1"/>
+          </a:fontRef>
+        </p:style>
+        <p:txBody>
+          <a:bodyPr rtlCol="0" anchor="ctr"/>
+          <a:lstStyle/>
+          <a:p>
+            <a:pPr algn="ctr"/>
+          </a:p>
+        </p:txBody>
+      </p:sp>
+      <p:sp>
+        <p:nvSpPr>
+          <p:cNvPr id="42" name="Rectangle 41"/>
+          <p:cNvSpPr/>
+          <p:nvPr/>
+        </p:nvSpPr>
+        <p:spPr>
+          <a:xfrm>
+            <a:off x="9239783" y="2066544"/>
+            <a:ext cx="1024128" cy="91440"/>
+          </a:xfrm>
+          <a:prstGeom prst="rect">
             <a:avLst/>
           </a:prstGeom>
           <a:solidFill>
@@ -7219,47 +7880,95 @@
       </p:sp>
       <p:sp>
         <p:nvSpPr>
-          <p:cNvPr id="42" name="TextBox 41"/>
-          <p:cNvSpPr txBox="1"/>
-          <p:nvPr/>
-        </p:nvSpPr>
-        <p:spPr>
-          <a:xfrm>
-            <a:off x="9294647" y="2018995"/>
-            <a:ext cx="420624" cy="420624"/>
-          </a:xfrm>
-          <a:prstGeom prst="rect">
-            <a:avLst/>
-          </a:prstGeom>
-          <a:noFill/>
-        </p:spPr>
-        <p:txBody>
-          <a:bodyPr wrap="square" anchor="ctr" lIns="0" rIns="0" tIns="0" bIns="0">
-            <a:spAutoFit/>
-          </a:bodyPr>
-          <a:lstStyle/>
-          <a:p>
-            <a:pPr algn="ctr">
-              <a:lnSpc>
-                <a:spcPct val="100000"/>
-              </a:lnSpc>
-            </a:pPr>
-            <a:r>
-              <a:rPr sz="1250" b="1">
-                <a:solidFill>
-                  <a:srgbClr val="FFFFFF"/>
-                </a:solidFill>
-                <a:latin typeface="Calibri"/>
-                <a:ea typeface="Calibri"/>
-              </a:rPr>
-              <a:t>04</a:t>
-            </a:r>
-          </a:p>
-        </p:txBody>
-      </p:sp>
-      <p:sp>
-        <p:nvSpPr>
-          <p:cNvPr id="43" name="TextBox 42"/>
+          <p:cNvPr id="43" name="Rectangle 42"/>
+          <p:cNvSpPr/>
+          <p:nvPr/>
+        </p:nvSpPr>
+        <p:spPr>
+          <a:xfrm>
+            <a:off x="9404375" y="2157984"/>
+            <a:ext cx="64008" cy="182880"/>
+          </a:xfrm>
+          <a:prstGeom prst="rect">
+            <a:avLst/>
+          </a:prstGeom>
+          <a:solidFill>
+            <a:srgbClr val="36A9E0"/>
+          </a:solidFill>
+          <a:ln>
+            <a:noFill/>
+          </a:ln>
+          <a:effectLst/>
+        </p:spPr>
+        <p:style>
+          <a:lnRef idx="1">
+            <a:schemeClr val="accent1"/>
+          </a:lnRef>
+          <a:fillRef idx="3">
+            <a:schemeClr val="accent1"/>
+          </a:fillRef>
+          <a:effectRef idx="2">
+            <a:schemeClr val="accent1"/>
+          </a:effectRef>
+          <a:fontRef idx="minor">
+            <a:schemeClr val="lt1"/>
+          </a:fontRef>
+        </p:style>
+        <p:txBody>
+          <a:bodyPr rtlCol="0" anchor="ctr"/>
+          <a:lstStyle/>
+          <a:p>
+            <a:pPr algn="ctr"/>
+          </a:p>
+        </p:txBody>
+      </p:sp>
+      <p:sp>
+        <p:nvSpPr>
+          <p:cNvPr id="44" name="Rectangle 43"/>
+          <p:cNvSpPr/>
+          <p:nvPr/>
+        </p:nvSpPr>
+        <p:spPr>
+          <a:xfrm>
+            <a:off x="10035311" y="2157984"/>
+            <a:ext cx="64008" cy="182880"/>
+          </a:xfrm>
+          <a:prstGeom prst="rect">
+            <a:avLst/>
+          </a:prstGeom>
+          <a:solidFill>
+            <a:srgbClr val="36A9E0"/>
+          </a:solidFill>
+          <a:ln>
+            <a:noFill/>
+          </a:ln>
+          <a:effectLst/>
+        </p:spPr>
+        <p:style>
+          <a:lnRef idx="1">
+            <a:schemeClr val="accent1"/>
+          </a:lnRef>
+          <a:fillRef idx="3">
+            <a:schemeClr val="accent1"/>
+          </a:fillRef>
+          <a:effectRef idx="2">
+            <a:schemeClr val="accent1"/>
+          </a:effectRef>
+          <a:fontRef idx="minor">
+            <a:schemeClr val="lt1"/>
+          </a:fontRef>
+        </p:style>
+        <p:txBody>
+          <a:bodyPr rtlCol="0" anchor="ctr"/>
+          <a:lstStyle/>
+          <a:p>
+            <a:pPr algn="ctr"/>
+          </a:p>
+        </p:txBody>
+      </p:sp>
+      <p:sp>
+        <p:nvSpPr>
+          <p:cNvPr id="45" name="TextBox 44"/>
           <p:cNvSpPr txBox="1"/>
           <p:nvPr/>
         </p:nvSpPr>
@@ -7299,7 +8008,7 @@
       </p:sp>
       <p:sp>
         <p:nvSpPr>
-          <p:cNvPr id="44" name="TextBox 43"/>
+          <p:cNvPr id="46" name="TextBox 45"/>
           <p:cNvSpPr txBox="1"/>
           <p:nvPr/>
         </p:nvSpPr>
@@ -7339,7 +8048,7 @@
       </p:sp>
       <p:cxnSp>
         <p:nvCxnSpPr>
-          <p:cNvPr id="45" name="Connector 44"/>
+          <p:cNvPr id="47" name="Connector 46"/>
           <p:cNvCxnSpPr/>
           <p:nvPr/>
         </p:nvCxnSpPr>
@@ -7375,7 +8084,7 @@
       </p:cxnSp>
       <p:sp>
         <p:nvSpPr>
-          <p:cNvPr id="46" name="TextBox 45"/>
+          <p:cNvPr id="48" name="TextBox 47"/>
           <p:cNvSpPr txBox="1"/>
           <p:nvPr/>
         </p:nvSpPr>
@@ -8002,7 +8711,13 @@
               <a:srgbClr val="D9E2EC"/>
             </a:solidFill>
           </a:ln>
-          <a:effectLst/>
+          <a:effectLst>
+            <a:outerShdw blurRad="140000" dist="50000" dir="5400000" rotWithShape="0">
+              <a:srgbClr val="16314E">
+                <a:alpha val="15000"/>
+              </a:srgbClr>
+            </a:outerShdw>
+          </a:effectLst>
         </p:spPr>
         <p:style>
           <a:lnRef idx="1">
@@ -8174,7 +8889,13 @@
               <a:srgbClr val="D9E2EC"/>
             </a:solidFill>
           </a:ln>
-          <a:effectLst/>
+          <a:effectLst>
+            <a:outerShdw blurRad="140000" dist="50000" dir="5400000" rotWithShape="0">
+              <a:srgbClr val="16314E">
+                <a:alpha val="15000"/>
+              </a:srgbClr>
+            </a:outerShdw>
+          </a:effectLst>
         </p:spPr>
         <p:style>
           <a:lnRef idx="1">
@@ -8346,7 +9067,13 @@
               <a:srgbClr val="D9E2EC"/>
             </a:solidFill>
           </a:ln>
-          <a:effectLst/>
+          <a:effectLst>
+            <a:outerShdw blurRad="140000" dist="50000" dir="5400000" rotWithShape="0">
+              <a:srgbClr val="16314E">
+                <a:alpha val="15000"/>
+              </a:srgbClr>
+            </a:outerShdw>
+          </a:effectLst>
         </p:spPr>
         <p:style>
           <a:lnRef idx="1">
@@ -10090,7 +10817,13 @@
               <a:srgbClr val="D9E2EC"/>
             </a:solidFill>
           </a:ln>
-          <a:effectLst/>
+          <a:effectLst>
+            <a:outerShdw blurRad="140000" dist="50000" dir="5400000" rotWithShape="0">
+              <a:srgbClr val="16314E">
+                <a:alpha val="15000"/>
+              </a:srgbClr>
+            </a:outerShdw>
+          </a:effectLst>
         </p:spPr>
         <p:style>
           <a:lnRef idx="1">
@@ -10262,7 +10995,13 @@
               <a:srgbClr val="D9E2EC"/>
             </a:solidFill>
           </a:ln>
-          <a:effectLst/>
+          <a:effectLst>
+            <a:outerShdw blurRad="140000" dist="50000" dir="5400000" rotWithShape="0">
+              <a:srgbClr val="16314E">
+                <a:alpha val="15000"/>
+              </a:srgbClr>
+            </a:outerShdw>
+          </a:effectLst>
         </p:spPr>
         <p:style>
           <a:lnRef idx="1">
@@ -10434,7 +11173,13 @@
               <a:srgbClr val="D9E2EC"/>
             </a:solidFill>
           </a:ln>
-          <a:effectLst/>
+          <a:effectLst>
+            <a:outerShdw blurRad="140000" dist="50000" dir="5400000" rotWithShape="0">
+              <a:srgbClr val="16314E">
+                <a:alpha val="15000"/>
+              </a:srgbClr>
+            </a:outerShdw>
+          </a:effectLst>
         </p:spPr>
         <p:style>
           <a:lnRef idx="1">
@@ -11161,7 +11906,13 @@
               <a:srgbClr val="D9E2EC"/>
             </a:solidFill>
           </a:ln>
-          <a:effectLst/>
+          <a:effectLst>
+            <a:outerShdw blurRad="140000" dist="50000" dir="5400000" rotWithShape="0">
+              <a:srgbClr val="16314E">
+                <a:alpha val="15000"/>
+              </a:srgbClr>
+            </a:outerShdw>
+          </a:effectLst>
         </p:spPr>
         <p:style>
           <a:lnRef idx="1">
@@ -11501,7 +12252,13 @@
               <a:srgbClr val="D9E2EC"/>
             </a:solidFill>
           </a:ln>
-          <a:effectLst/>
+          <a:effectLst>
+            <a:outerShdw blurRad="140000" dist="50000" dir="5400000" rotWithShape="0">
+              <a:srgbClr val="16314E">
+                <a:alpha val="15000"/>
+              </a:srgbClr>
+            </a:outerShdw>
+          </a:effectLst>
         </p:spPr>
         <p:style>
           <a:lnRef idx="1">
@@ -11841,7 +12598,13 @@
               <a:srgbClr val="D9E2EC"/>
             </a:solidFill>
           </a:ln>
-          <a:effectLst/>
+          <a:effectLst>
+            <a:outerShdw blurRad="140000" dist="50000" dir="5400000" rotWithShape="0">
+              <a:srgbClr val="16314E">
+                <a:alpha val="15000"/>
+              </a:srgbClr>
+            </a:outerShdw>
+          </a:effectLst>
         </p:spPr>
         <p:style>
           <a:lnRef idx="1">
@@ -12181,7 +12944,13 @@
               <a:srgbClr val="D9E2EC"/>
             </a:solidFill>
           </a:ln>
-          <a:effectLst/>
+          <a:effectLst>
+            <a:outerShdw blurRad="140000" dist="50000" dir="5400000" rotWithShape="0">
+              <a:srgbClr val="16314E">
+                <a:alpha val="15000"/>
+              </a:srgbClr>
+            </a:outerShdw>
+          </a:effectLst>
         </p:spPr>
         <p:style>
           <a:lnRef idx="1">
@@ -15291,7 +16060,7 @@
     <a:masterClrMapping/>
   </p:clrMapOvr>
   <p:transition spd="med">
-    <p:fade/>
+    <p:fade thruBlk="1"/>
   </p:transition>
 </p:sld>
 </file>
@@ -16409,7 +17178,13 @@
               <a:srgbClr val="D9E2EC"/>
             </a:solidFill>
           </a:ln>
-          <a:effectLst/>
+          <a:effectLst>
+            <a:outerShdw blurRad="140000" dist="50000" dir="5400000" rotWithShape="0">
+              <a:srgbClr val="16314E">
+                <a:alpha val="15000"/>
+              </a:srgbClr>
+            </a:outerShdw>
+          </a:effectLst>
         </p:spPr>
         <p:style>
           <a:lnRef idx="1">
@@ -16665,7 +17440,13 @@
               <a:srgbClr val="D9E2EC"/>
             </a:solidFill>
           </a:ln>
-          <a:effectLst/>
+          <a:effectLst>
+            <a:outerShdw blurRad="140000" dist="50000" dir="5400000" rotWithShape="0">
+              <a:srgbClr val="16314E">
+                <a:alpha val="15000"/>
+              </a:srgbClr>
+            </a:outerShdw>
+          </a:effectLst>
         </p:spPr>
         <p:style>
           <a:lnRef idx="1">
@@ -16921,7 +17702,13 @@
               <a:srgbClr val="D9E2EC"/>
             </a:solidFill>
           </a:ln>
-          <a:effectLst/>
+          <a:effectLst>
+            <a:outerShdw blurRad="140000" dist="50000" dir="5400000" rotWithShape="0">
+              <a:srgbClr val="16314E">
+                <a:alpha val="15000"/>
+              </a:srgbClr>
+            </a:outerShdw>
+          </a:effectLst>
         </p:spPr>
         <p:style>
           <a:lnRef idx="1">
@@ -17177,7 +17964,13 @@
               <a:srgbClr val="D9E2EC"/>
             </a:solidFill>
           </a:ln>
-          <a:effectLst/>
+          <a:effectLst>
+            <a:outerShdw blurRad="140000" dist="50000" dir="5400000" rotWithShape="0">
+              <a:srgbClr val="16314E">
+                <a:alpha val="15000"/>
+              </a:srgbClr>
+            </a:outerShdw>
+          </a:effectLst>
         </p:spPr>
         <p:style>
           <a:lnRef idx="1">
@@ -17988,7 +18781,13 @@
               <a:srgbClr val="D9E2EC"/>
             </a:solidFill>
           </a:ln>
-          <a:effectLst/>
+          <a:effectLst>
+            <a:outerShdw blurRad="140000" dist="50000" dir="5400000" rotWithShape="0">
+              <a:srgbClr val="16314E">
+                <a:alpha val="15000"/>
+              </a:srgbClr>
+            </a:outerShdw>
+          </a:effectLst>
         </p:spPr>
         <p:style>
           <a:lnRef idx="1">
@@ -18567,7 +19366,13 @@
               <a:srgbClr val="D9E2EC"/>
             </a:solidFill>
           </a:ln>
-          <a:effectLst/>
+          <a:effectLst>
+            <a:outerShdw blurRad="140000" dist="50000" dir="5400000" rotWithShape="0">
+              <a:srgbClr val="16314E">
+                <a:alpha val="15000"/>
+              </a:srgbClr>
+            </a:outerShdw>
+          </a:effectLst>
         </p:spPr>
         <p:style>
           <a:lnRef idx="1">
@@ -18928,7 +19733,13 @@
               <a:srgbClr val="D9E2EC"/>
             </a:solidFill>
           </a:ln>
-          <a:effectLst/>
+          <a:effectLst>
+            <a:outerShdw blurRad="140000" dist="50000" dir="5400000" rotWithShape="0">
+              <a:srgbClr val="16314E">
+                <a:alpha val="15000"/>
+              </a:srgbClr>
+            </a:outerShdw>
+          </a:effectLst>
         </p:spPr>
         <p:style>
           <a:lnRef idx="1">
@@ -19459,7 +20270,13 @@
               <a:srgbClr val="D9E2EC"/>
             </a:solidFill>
           </a:ln>
-          <a:effectLst/>
+          <a:effectLst>
+            <a:outerShdw blurRad="140000" dist="50000" dir="5400000" rotWithShape="0">
+              <a:srgbClr val="16314E">
+                <a:alpha val="15000"/>
+              </a:srgbClr>
+            </a:outerShdw>
+          </a:effectLst>
         </p:spPr>
         <p:style>
           <a:lnRef idx="1">
@@ -20419,7 +21236,13 @@
               <a:srgbClr val="D9E2EC"/>
             </a:solidFill>
           </a:ln>
-          <a:effectLst/>
+          <a:effectLst>
+            <a:outerShdw blurRad="140000" dist="50000" dir="5400000" rotWithShape="0">
+              <a:srgbClr val="16314E">
+                <a:alpha val="15000"/>
+              </a:srgbClr>
+            </a:outerShdw>
+          </a:effectLst>
         </p:spPr>
         <p:style>
           <a:lnRef idx="1">
@@ -20489,14 +21312,151 @@
       </p:sp>
       <p:sp>
         <p:nvSpPr>
-          <p:cNvPr id="17" name="TextBox 16"/>
+          <p:cNvPr id="17" name="Donut 16"/>
+          <p:cNvSpPr/>
+          <p:nvPr/>
+        </p:nvSpPr>
+        <p:spPr>
+          <a:xfrm>
+            <a:off x="859536" y="2066544"/>
+            <a:ext cx="1417320" cy="1417320"/>
+          </a:xfrm>
+          <a:prstGeom prst="donut">
+            <a:avLst>
+              <a:gd name="adj" fmla="val 16000"/>
+            </a:avLst>
+          </a:prstGeom>
+          <a:solidFill>
+            <a:srgbClr val="EAF0F6"/>
+          </a:solidFill>
+          <a:ln>
+            <a:noFill/>
+          </a:ln>
+          <a:effectLst/>
+        </p:spPr>
+        <p:style>
+          <a:lnRef idx="1">
+            <a:schemeClr val="accent1"/>
+          </a:lnRef>
+          <a:fillRef idx="3">
+            <a:schemeClr val="accent1"/>
+          </a:fillRef>
+          <a:effectRef idx="2">
+            <a:schemeClr val="accent1"/>
+          </a:effectRef>
+          <a:fontRef idx="minor">
+            <a:schemeClr val="lt1"/>
+          </a:fontRef>
+        </p:style>
+        <p:txBody>
+          <a:bodyPr rtlCol="0" anchor="ctr"/>
+          <a:lstStyle/>
+          <a:p>
+            <a:pPr algn="ctr"/>
+          </a:p>
+        </p:txBody>
+      </p:sp>
+      <p:sp>
+        <p:nvSpPr>
+          <p:cNvPr id="18" name="Pie 17"/>
+          <p:cNvSpPr/>
+          <p:nvPr/>
+        </p:nvSpPr>
+        <p:spPr>
+          <a:xfrm>
+            <a:off x="859536" y="2066544"/>
+            <a:ext cx="1417320" cy="1417320"/>
+          </a:xfrm>
+          <a:prstGeom prst="pie">
+            <a:avLst>
+              <a:gd name="adj1" fmla="val 16200000"/>
+              <a:gd name="adj2" fmla="val 3240000"/>
+            </a:avLst>
+          </a:prstGeom>
+          <a:solidFill>
+            <a:srgbClr val="1F6FB2"/>
+          </a:solidFill>
+          <a:ln>
+            <a:noFill/>
+          </a:ln>
+          <a:effectLst/>
+        </p:spPr>
+        <p:style>
+          <a:lnRef idx="1">
+            <a:schemeClr val="accent1"/>
+          </a:lnRef>
+          <a:fillRef idx="3">
+            <a:schemeClr val="accent1"/>
+          </a:fillRef>
+          <a:effectRef idx="2">
+            <a:schemeClr val="accent1"/>
+          </a:effectRef>
+          <a:fontRef idx="minor">
+            <a:schemeClr val="lt1"/>
+          </a:fontRef>
+        </p:style>
+        <p:txBody>
+          <a:bodyPr rtlCol="0" anchor="ctr"/>
+          <a:lstStyle/>
+          <a:p>
+            <a:pPr algn="ctr"/>
+          </a:p>
+        </p:txBody>
+      </p:sp>
+      <p:sp>
+        <p:nvSpPr>
+          <p:cNvPr id="19" name="Oval 18"/>
+          <p:cNvSpPr/>
+          <p:nvPr/>
+        </p:nvSpPr>
+        <p:spPr>
+          <a:xfrm>
+            <a:off x="1086307" y="2293315"/>
+            <a:ext cx="963777" cy="963777"/>
+          </a:xfrm>
+          <a:prstGeom prst="ellipse">
+            <a:avLst/>
+          </a:prstGeom>
+          <a:solidFill>
+            <a:srgbClr val="FFFFFF"/>
+          </a:solidFill>
+          <a:ln>
+            <a:noFill/>
+          </a:ln>
+          <a:effectLst/>
+        </p:spPr>
+        <p:style>
+          <a:lnRef idx="1">
+            <a:schemeClr val="accent1"/>
+          </a:lnRef>
+          <a:fillRef idx="3">
+            <a:schemeClr val="accent1"/>
+          </a:fillRef>
+          <a:effectRef idx="2">
+            <a:schemeClr val="accent1"/>
+          </a:effectRef>
+          <a:fontRef idx="minor">
+            <a:schemeClr val="lt1"/>
+          </a:fontRef>
+        </p:style>
+        <p:txBody>
+          <a:bodyPr rtlCol="0" anchor="ctr"/>
+          <a:lstStyle/>
+          <a:p>
+            <a:pPr algn="ctr"/>
+          </a:p>
+        </p:txBody>
+      </p:sp>
+      <p:sp>
+        <p:nvSpPr>
+          <p:cNvPr id="20" name="TextBox 19"/>
           <p:cNvSpPr txBox="1"/>
           <p:nvPr/>
         </p:nvSpPr>
         <p:spPr>
           <a:xfrm>
-            <a:off x="859536" y="2011680"/>
-            <a:ext cx="2917850" cy="914400"/>
+            <a:off x="859536" y="2048256"/>
+            <a:ext cx="1417320" cy="1417320"/>
           </a:xfrm>
           <a:prstGeom prst="rect">
             <a:avLst/>
@@ -20504,18 +21464,18 @@
           <a:noFill/>
         </p:spPr>
         <p:txBody>
-          <a:bodyPr wrap="square" anchor="t" lIns="0" rIns="0" tIns="0" bIns="0">
+          <a:bodyPr wrap="square" anchor="ctr" lIns="0" rIns="0" tIns="0" bIns="0">
             <a:spAutoFit/>
           </a:bodyPr>
           <a:lstStyle/>
           <a:p>
-            <a:pPr algn="l">
+            <a:pPr algn="ctr">
               <a:lnSpc>
                 <a:spcPct val="100000"/>
               </a:lnSpc>
             </a:pPr>
             <a:r>
-              <a:rPr sz="5000" b="1">
+              <a:rPr sz="2100" b="1">
                 <a:solidFill>
                   <a:srgbClr val="1F6FB2"/>
                 </a:solidFill>
@@ -20529,105 +21489,70 @@
       </p:sp>
       <p:sp>
         <p:nvSpPr>
-          <p:cNvPr id="18" name="Rounded Rectangle 17"/>
-          <p:cNvSpPr/>
-          <p:nvPr/>
-        </p:nvSpPr>
-        <p:spPr>
-          <a:xfrm>
-            <a:off x="859536" y="3054096"/>
-            <a:ext cx="2917850" cy="128016"/>
-          </a:xfrm>
-          <a:prstGeom prst="roundRect">
-            <a:avLst>
-              <a:gd name="adj" fmla="val 50000"/>
-            </a:avLst>
-          </a:prstGeom>
-          <a:solidFill>
-            <a:srgbClr val="EAF0F6"/>
-          </a:solidFill>
-          <a:ln>
-            <a:noFill/>
-          </a:ln>
-          <a:effectLst/>
-        </p:spPr>
-        <p:style>
-          <a:lnRef idx="1">
-            <a:schemeClr val="accent1"/>
-          </a:lnRef>
-          <a:fillRef idx="3">
-            <a:schemeClr val="accent1"/>
-          </a:fillRef>
-          <a:effectRef idx="2">
-            <a:schemeClr val="accent1"/>
-          </a:effectRef>
-          <a:fontRef idx="minor">
-            <a:schemeClr val="lt1"/>
-          </a:fontRef>
-        </p:style>
-        <p:txBody>
-          <a:bodyPr rtlCol="0" anchor="ctr"/>
-          <a:lstStyle/>
-          <a:p>
-            <a:pPr algn="ctr"/>
-          </a:p>
-        </p:txBody>
-      </p:sp>
-      <p:sp>
-        <p:nvSpPr>
-          <p:cNvPr id="19" name="Rounded Rectangle 18"/>
-          <p:cNvSpPr/>
-          <p:nvPr/>
-        </p:nvSpPr>
-        <p:spPr>
-          <a:xfrm>
-            <a:off x="859536" y="3054096"/>
-            <a:ext cx="1167140" cy="128016"/>
-          </a:xfrm>
-          <a:prstGeom prst="roundRect">
-            <a:avLst>
-              <a:gd name="adj" fmla="val 50000"/>
-            </a:avLst>
-          </a:prstGeom>
-          <a:solidFill>
-            <a:srgbClr val="1F6FB2"/>
-          </a:solidFill>
-          <a:ln>
-            <a:noFill/>
-          </a:ln>
-          <a:effectLst/>
-        </p:spPr>
-        <p:style>
-          <a:lnRef idx="1">
-            <a:schemeClr val="accent1"/>
-          </a:lnRef>
-          <a:fillRef idx="3">
-            <a:schemeClr val="accent1"/>
-          </a:fillRef>
-          <a:effectRef idx="2">
-            <a:schemeClr val="accent1"/>
-          </a:effectRef>
-          <a:fontRef idx="minor">
-            <a:schemeClr val="lt1"/>
-          </a:fontRef>
-        </p:style>
-        <p:txBody>
-          <a:bodyPr rtlCol="0" anchor="ctr"/>
-          <a:lstStyle/>
-          <a:p>
-            <a:pPr algn="ctr"/>
-          </a:p>
-        </p:txBody>
-      </p:sp>
-      <p:sp>
-        <p:nvSpPr>
-          <p:cNvPr id="20" name="TextBox 19"/>
+          <p:cNvPr id="21" name="TextBox 20"/>
           <p:cNvSpPr txBox="1"/>
           <p:nvPr/>
         </p:nvSpPr>
         <p:spPr>
           <a:xfrm>
-            <a:off x="859536" y="3364991"/>
+            <a:off x="2487168" y="2066544"/>
+            <a:ext cx="1354226" cy="1463040"/>
+          </a:xfrm>
+          <a:prstGeom prst="rect">
+            <a:avLst/>
+          </a:prstGeom>
+          <a:noFill/>
+        </p:spPr>
+        <p:txBody>
+          <a:bodyPr wrap="square" anchor="ctr" lIns="0" rIns="0" tIns="0" bIns="0">
+            <a:spAutoFit/>
+          </a:bodyPr>
+          <a:lstStyle/>
+          <a:p>
+            <a:pPr algn="l">
+              <a:lnSpc>
+                <a:spcPct val="115000"/>
+              </a:lnSpc>
+            </a:pPr>
+            <a:r>
+              <a:rPr sz="1200" b="0">
+                <a:solidFill>
+                  <a:srgbClr val="5B7083"/>
+                </a:solidFill>
+                <a:latin typeface="Calibri"/>
+                <a:ea typeface="Calibri"/>
+              </a:rPr>
+              <a:t>of tray</a:t>
+            </a:r>
+          </a:p>
+          <a:p>
+            <a:pPr algn="l">
+              <a:lnSpc>
+                <a:spcPct val="115000"/>
+              </a:lnSpc>
+            </a:pPr>
+            <a:r>
+              <a:rPr sz="1200" b="0">
+                <a:solidFill>
+                  <a:srgbClr val="5B7083"/>
+                </a:solidFill>
+                <a:latin typeface="Calibri"/>
+                <a:ea typeface="Calibri"/>
+              </a:rPr>
+              <a:t>cross-section</a:t>
+            </a:r>
+          </a:p>
+        </p:txBody>
+      </p:sp>
+      <p:sp>
+        <p:nvSpPr>
+          <p:cNvPr id="22" name="TextBox 21"/>
+          <p:cNvSpPr txBox="1"/>
+          <p:nvPr/>
+        </p:nvSpPr>
+        <p:spPr>
+          <a:xfrm>
+            <a:off x="859536" y="3694176"/>
             <a:ext cx="2917850" cy="457200"/>
           </a:xfrm>
           <a:prstGeom prst="rect">
@@ -20661,14 +21586,14 @@
       </p:sp>
       <p:sp>
         <p:nvSpPr>
-          <p:cNvPr id="21" name="TextBox 20"/>
+          <p:cNvPr id="23" name="TextBox 22"/>
           <p:cNvSpPr txBox="1"/>
           <p:nvPr/>
         </p:nvSpPr>
         <p:spPr>
           <a:xfrm>
-            <a:off x="859536" y="3803904"/>
-            <a:ext cx="2917850" cy="1280160"/>
+            <a:off x="859536" y="4133088"/>
+            <a:ext cx="2917850" cy="1188720"/>
           </a:xfrm>
           <a:prstGeom prst="rect">
             <a:avLst/>
@@ -20701,7 +21626,7 @@
       </p:sp>
       <p:sp>
         <p:nvSpPr>
-          <p:cNvPr id="22" name="Rounded Rectangle 21"/>
+          <p:cNvPr id="24" name="Rounded Rectangle 23"/>
           <p:cNvSpPr/>
           <p:nvPr/>
         </p:nvSpPr>
@@ -20723,7 +21648,13 @@
               <a:srgbClr val="D9E2EC"/>
             </a:solidFill>
           </a:ln>
-          <a:effectLst/>
+          <a:effectLst>
+            <a:outerShdw blurRad="140000" dist="50000" dir="5400000" rotWithShape="0">
+              <a:srgbClr val="16314E">
+                <a:alpha val="15000"/>
+              </a:srgbClr>
+            </a:outerShdw>
+          </a:effectLst>
         </p:spPr>
         <p:style>
           <a:lnRef idx="1">
@@ -20749,7 +21680,7 @@
       </p:sp>
       <p:sp>
         <p:nvSpPr>
-          <p:cNvPr id="23" name="Rectangle 22"/>
+          <p:cNvPr id="25" name="Rectangle 24"/>
           <p:cNvSpPr/>
           <p:nvPr/>
         </p:nvSpPr>
@@ -20793,14 +21724,151 @@
       </p:sp>
       <p:sp>
         <p:nvSpPr>
-          <p:cNvPr id="24" name="TextBox 23"/>
+          <p:cNvPr id="26" name="Donut 25"/>
+          <p:cNvSpPr/>
+          <p:nvPr/>
+        </p:nvSpPr>
+        <p:spPr>
+          <a:xfrm>
+            <a:off x="4636922" y="2066544"/>
+            <a:ext cx="1417320" cy="1417320"/>
+          </a:xfrm>
+          <a:prstGeom prst="donut">
+            <a:avLst>
+              <a:gd name="adj" fmla="val 16000"/>
+            </a:avLst>
+          </a:prstGeom>
+          <a:solidFill>
+            <a:srgbClr val="EAF0F6"/>
+          </a:solidFill>
+          <a:ln>
+            <a:noFill/>
+          </a:ln>
+          <a:effectLst/>
+        </p:spPr>
+        <p:style>
+          <a:lnRef idx="1">
+            <a:schemeClr val="accent1"/>
+          </a:lnRef>
+          <a:fillRef idx="3">
+            <a:schemeClr val="accent1"/>
+          </a:fillRef>
+          <a:effectRef idx="2">
+            <a:schemeClr val="accent1"/>
+          </a:effectRef>
+          <a:fontRef idx="minor">
+            <a:schemeClr val="lt1"/>
+          </a:fontRef>
+        </p:style>
+        <p:txBody>
+          <a:bodyPr rtlCol="0" anchor="ctr"/>
+          <a:lstStyle/>
+          <a:p>
+            <a:pPr algn="ctr"/>
+          </a:p>
+        </p:txBody>
+      </p:sp>
+      <p:sp>
+        <p:nvSpPr>
+          <p:cNvPr id="27" name="Pie 26"/>
+          <p:cNvSpPr/>
+          <p:nvPr/>
+        </p:nvSpPr>
+        <p:spPr>
+          <a:xfrm>
+            <a:off x="4636922" y="2066544"/>
+            <a:ext cx="1417320" cy="1417320"/>
+          </a:xfrm>
+          <a:prstGeom prst="pie">
+            <a:avLst>
+              <a:gd name="adj1" fmla="val 16200000"/>
+              <a:gd name="adj2" fmla="val 5400000"/>
+            </a:avLst>
+          </a:prstGeom>
+          <a:solidFill>
+            <a:srgbClr val="36A9E0"/>
+          </a:solidFill>
+          <a:ln>
+            <a:noFill/>
+          </a:ln>
+          <a:effectLst/>
+        </p:spPr>
+        <p:style>
+          <a:lnRef idx="1">
+            <a:schemeClr val="accent1"/>
+          </a:lnRef>
+          <a:fillRef idx="3">
+            <a:schemeClr val="accent1"/>
+          </a:fillRef>
+          <a:effectRef idx="2">
+            <a:schemeClr val="accent1"/>
+          </a:effectRef>
+          <a:fontRef idx="minor">
+            <a:schemeClr val="lt1"/>
+          </a:fontRef>
+        </p:style>
+        <p:txBody>
+          <a:bodyPr rtlCol="0" anchor="ctr"/>
+          <a:lstStyle/>
+          <a:p>
+            <a:pPr algn="ctr"/>
+          </a:p>
+        </p:txBody>
+      </p:sp>
+      <p:sp>
+        <p:nvSpPr>
+          <p:cNvPr id="28" name="Oval 27"/>
+          <p:cNvSpPr/>
+          <p:nvPr/>
+        </p:nvSpPr>
+        <p:spPr>
+          <a:xfrm>
+            <a:off x="4863693" y="2293315"/>
+            <a:ext cx="963777" cy="963777"/>
+          </a:xfrm>
+          <a:prstGeom prst="ellipse">
+            <a:avLst/>
+          </a:prstGeom>
+          <a:solidFill>
+            <a:srgbClr val="FFFFFF"/>
+          </a:solidFill>
+          <a:ln>
+            <a:noFill/>
+          </a:ln>
+          <a:effectLst/>
+        </p:spPr>
+        <p:style>
+          <a:lnRef idx="1">
+            <a:schemeClr val="accent1"/>
+          </a:lnRef>
+          <a:fillRef idx="3">
+            <a:schemeClr val="accent1"/>
+          </a:fillRef>
+          <a:effectRef idx="2">
+            <a:schemeClr val="accent1"/>
+          </a:effectRef>
+          <a:fontRef idx="minor">
+            <a:schemeClr val="lt1"/>
+          </a:fontRef>
+        </p:style>
+        <p:txBody>
+          <a:bodyPr rtlCol="0" anchor="ctr"/>
+          <a:lstStyle/>
+          <a:p>
+            <a:pPr algn="ctr"/>
+          </a:p>
+        </p:txBody>
+      </p:sp>
+      <p:sp>
+        <p:nvSpPr>
+          <p:cNvPr id="29" name="TextBox 28"/>
           <p:cNvSpPr txBox="1"/>
           <p:nvPr/>
         </p:nvSpPr>
         <p:spPr>
           <a:xfrm>
-            <a:off x="4636922" y="2011680"/>
-            <a:ext cx="2917850" cy="914400"/>
+            <a:off x="4636922" y="2048256"/>
+            <a:ext cx="1417320" cy="1417320"/>
           </a:xfrm>
           <a:prstGeom prst="rect">
             <a:avLst/>
@@ -20808,18 +21876,18 @@
           <a:noFill/>
         </p:spPr>
         <p:txBody>
-          <a:bodyPr wrap="square" anchor="t" lIns="0" rIns="0" tIns="0" bIns="0">
+          <a:bodyPr wrap="square" anchor="ctr" lIns="0" rIns="0" tIns="0" bIns="0">
             <a:spAutoFit/>
           </a:bodyPr>
           <a:lstStyle/>
           <a:p>
-            <a:pPr algn="l">
+            <a:pPr algn="ctr">
               <a:lnSpc>
                 <a:spcPct val="100000"/>
               </a:lnSpc>
             </a:pPr>
             <a:r>
-              <a:rPr sz="5000" b="1">
+              <a:rPr sz="2100" b="1">
                 <a:solidFill>
                   <a:srgbClr val="36A9E0"/>
                 </a:solidFill>
@@ -20833,105 +21901,70 @@
       </p:sp>
       <p:sp>
         <p:nvSpPr>
-          <p:cNvPr id="25" name="Rounded Rectangle 24"/>
-          <p:cNvSpPr/>
-          <p:nvPr/>
-        </p:nvSpPr>
-        <p:spPr>
-          <a:xfrm>
-            <a:off x="4636922" y="3054096"/>
-            <a:ext cx="2917850" cy="128016"/>
-          </a:xfrm>
-          <a:prstGeom prst="roundRect">
-            <a:avLst>
-              <a:gd name="adj" fmla="val 50000"/>
-            </a:avLst>
-          </a:prstGeom>
-          <a:solidFill>
-            <a:srgbClr val="EAF0F6"/>
-          </a:solidFill>
-          <a:ln>
-            <a:noFill/>
-          </a:ln>
-          <a:effectLst/>
-        </p:spPr>
-        <p:style>
-          <a:lnRef idx="1">
-            <a:schemeClr val="accent1"/>
-          </a:lnRef>
-          <a:fillRef idx="3">
-            <a:schemeClr val="accent1"/>
-          </a:fillRef>
-          <a:effectRef idx="2">
-            <a:schemeClr val="accent1"/>
-          </a:effectRef>
-          <a:fontRef idx="minor">
-            <a:schemeClr val="lt1"/>
-          </a:fontRef>
-        </p:style>
-        <p:txBody>
-          <a:bodyPr rtlCol="0" anchor="ctr"/>
-          <a:lstStyle/>
-          <a:p>
-            <a:pPr algn="ctr"/>
-          </a:p>
-        </p:txBody>
-      </p:sp>
-      <p:sp>
-        <p:nvSpPr>
-          <p:cNvPr id="26" name="Rounded Rectangle 25"/>
-          <p:cNvSpPr/>
-          <p:nvPr/>
-        </p:nvSpPr>
-        <p:spPr>
-          <a:xfrm>
-            <a:off x="4636922" y="3054096"/>
-            <a:ext cx="1458925" cy="128016"/>
-          </a:xfrm>
-          <a:prstGeom prst="roundRect">
-            <a:avLst>
-              <a:gd name="adj" fmla="val 50000"/>
-            </a:avLst>
-          </a:prstGeom>
-          <a:solidFill>
-            <a:srgbClr val="36A9E0"/>
-          </a:solidFill>
-          <a:ln>
-            <a:noFill/>
-          </a:ln>
-          <a:effectLst/>
-        </p:spPr>
-        <p:style>
-          <a:lnRef idx="1">
-            <a:schemeClr val="accent1"/>
-          </a:lnRef>
-          <a:fillRef idx="3">
-            <a:schemeClr val="accent1"/>
-          </a:fillRef>
-          <a:effectRef idx="2">
-            <a:schemeClr val="accent1"/>
-          </a:effectRef>
-          <a:fontRef idx="minor">
-            <a:schemeClr val="lt1"/>
-          </a:fontRef>
-        </p:style>
-        <p:txBody>
-          <a:bodyPr rtlCol="0" anchor="ctr"/>
-          <a:lstStyle/>
-          <a:p>
-            <a:pPr algn="ctr"/>
-          </a:p>
-        </p:txBody>
-      </p:sp>
-      <p:sp>
-        <p:nvSpPr>
-          <p:cNvPr id="27" name="TextBox 26"/>
+          <p:cNvPr id="30" name="TextBox 29"/>
           <p:cNvSpPr txBox="1"/>
           <p:nvPr/>
         </p:nvSpPr>
         <p:spPr>
           <a:xfrm>
-            <a:off x="4636922" y="3364991"/>
+            <a:off x="6264554" y="2066544"/>
+            <a:ext cx="1354226" cy="1463040"/>
+          </a:xfrm>
+          <a:prstGeom prst="rect">
+            <a:avLst/>
+          </a:prstGeom>
+          <a:noFill/>
+        </p:spPr>
+        <p:txBody>
+          <a:bodyPr wrap="square" anchor="ctr" lIns="0" rIns="0" tIns="0" bIns="0">
+            <a:spAutoFit/>
+          </a:bodyPr>
+          <a:lstStyle/>
+          <a:p>
+            <a:pPr algn="l">
+              <a:lnSpc>
+                <a:spcPct val="115000"/>
+              </a:lnSpc>
+            </a:pPr>
+            <a:r>
+              <a:rPr sz="1200" b="0">
+                <a:solidFill>
+                  <a:srgbClr val="5B7083"/>
+                </a:solidFill>
+                <a:latin typeface="Calibri"/>
+                <a:ea typeface="Calibri"/>
+              </a:rPr>
+              <a:t>of tray</a:t>
+            </a:r>
+          </a:p>
+          <a:p>
+            <a:pPr algn="l">
+              <a:lnSpc>
+                <a:spcPct val="115000"/>
+              </a:lnSpc>
+            </a:pPr>
+            <a:r>
+              <a:rPr sz="1200" b="0">
+                <a:solidFill>
+                  <a:srgbClr val="5B7083"/>
+                </a:solidFill>
+                <a:latin typeface="Calibri"/>
+                <a:ea typeface="Calibri"/>
+              </a:rPr>
+              <a:t>cross-section</a:t>
+            </a:r>
+          </a:p>
+        </p:txBody>
+      </p:sp>
+      <p:sp>
+        <p:nvSpPr>
+          <p:cNvPr id="31" name="TextBox 30"/>
+          <p:cNvSpPr txBox="1"/>
+          <p:nvPr/>
+        </p:nvSpPr>
+        <p:spPr>
+          <a:xfrm>
+            <a:off x="4636922" y="3694176"/>
             <a:ext cx="2917850" cy="457200"/>
           </a:xfrm>
           <a:prstGeom prst="rect">
@@ -20965,14 +21998,14 @@
       </p:sp>
       <p:sp>
         <p:nvSpPr>
-          <p:cNvPr id="28" name="TextBox 27"/>
+          <p:cNvPr id="32" name="TextBox 31"/>
           <p:cNvSpPr txBox="1"/>
           <p:nvPr/>
         </p:nvSpPr>
         <p:spPr>
           <a:xfrm>
-            <a:off x="4636922" y="3803904"/>
-            <a:ext cx="2917850" cy="1280160"/>
+            <a:off x="4636922" y="4133088"/>
+            <a:ext cx="2917850" cy="1188720"/>
           </a:xfrm>
           <a:prstGeom prst="rect">
             <a:avLst/>
@@ -21005,7 +22038,7 @@
       </p:sp>
       <p:sp>
         <p:nvSpPr>
-          <p:cNvPr id="29" name="Rounded Rectangle 28"/>
+          <p:cNvPr id="33" name="Rounded Rectangle 32"/>
           <p:cNvSpPr/>
           <p:nvPr/>
         </p:nvSpPr>
@@ -21027,7 +22060,13 @@
               <a:srgbClr val="D9E2EC"/>
             </a:solidFill>
           </a:ln>
-          <a:effectLst/>
+          <a:effectLst>
+            <a:outerShdw blurRad="140000" dist="50000" dir="5400000" rotWithShape="0">
+              <a:srgbClr val="16314E">
+                <a:alpha val="15000"/>
+              </a:srgbClr>
+            </a:outerShdw>
+          </a:effectLst>
         </p:spPr>
         <p:style>
           <a:lnRef idx="1">
@@ -21053,7 +22092,7 @@
       </p:sp>
       <p:sp>
         <p:nvSpPr>
-          <p:cNvPr id="30" name="Rectangle 29"/>
+          <p:cNvPr id="34" name="Rectangle 33"/>
           <p:cNvSpPr/>
           <p:nvPr/>
         </p:nvSpPr>
@@ -21097,14 +22136,151 @@
       </p:sp>
       <p:sp>
         <p:nvSpPr>
-          <p:cNvPr id="31" name="TextBox 30"/>
+          <p:cNvPr id="35" name="Donut 34"/>
+          <p:cNvSpPr/>
+          <p:nvPr/>
+        </p:nvSpPr>
+        <p:spPr>
+          <a:xfrm>
+            <a:off x="8414308" y="2066544"/>
+            <a:ext cx="1417320" cy="1417320"/>
+          </a:xfrm>
+          <a:prstGeom prst="donut">
+            <a:avLst>
+              <a:gd name="adj" fmla="val 16000"/>
+            </a:avLst>
+          </a:prstGeom>
+          <a:solidFill>
+            <a:srgbClr val="EAF0F6"/>
+          </a:solidFill>
+          <a:ln>
+            <a:noFill/>
+          </a:ln>
+          <a:effectLst/>
+        </p:spPr>
+        <p:style>
+          <a:lnRef idx="1">
+            <a:schemeClr val="accent1"/>
+          </a:lnRef>
+          <a:fillRef idx="3">
+            <a:schemeClr val="accent1"/>
+          </a:fillRef>
+          <a:effectRef idx="2">
+            <a:schemeClr val="accent1"/>
+          </a:effectRef>
+          <a:fontRef idx="minor">
+            <a:schemeClr val="lt1"/>
+          </a:fontRef>
+        </p:style>
+        <p:txBody>
+          <a:bodyPr rtlCol="0" anchor="ctr"/>
+          <a:lstStyle/>
+          <a:p>
+            <a:pPr algn="ctr"/>
+          </a:p>
+        </p:txBody>
+      </p:sp>
+      <p:sp>
+        <p:nvSpPr>
+          <p:cNvPr id="36" name="Pie 35"/>
+          <p:cNvSpPr/>
+          <p:nvPr/>
+        </p:nvSpPr>
+        <p:spPr>
+          <a:xfrm>
+            <a:off x="8414308" y="2066544"/>
+            <a:ext cx="1417320" cy="1417320"/>
+          </a:xfrm>
+          <a:prstGeom prst="pie">
+            <a:avLst>
+              <a:gd name="adj1" fmla="val 16200000"/>
+              <a:gd name="adj2" fmla="val 20520000"/>
+            </a:avLst>
+          </a:prstGeom>
+          <a:solidFill>
+            <a:srgbClr val="F5A623"/>
+          </a:solidFill>
+          <a:ln>
+            <a:noFill/>
+          </a:ln>
+          <a:effectLst/>
+        </p:spPr>
+        <p:style>
+          <a:lnRef idx="1">
+            <a:schemeClr val="accent1"/>
+          </a:lnRef>
+          <a:fillRef idx="3">
+            <a:schemeClr val="accent1"/>
+          </a:fillRef>
+          <a:effectRef idx="2">
+            <a:schemeClr val="accent1"/>
+          </a:effectRef>
+          <a:fontRef idx="minor">
+            <a:schemeClr val="lt1"/>
+          </a:fontRef>
+        </p:style>
+        <p:txBody>
+          <a:bodyPr rtlCol="0" anchor="ctr"/>
+          <a:lstStyle/>
+          <a:p>
+            <a:pPr algn="ctr"/>
+          </a:p>
+        </p:txBody>
+      </p:sp>
+      <p:sp>
+        <p:nvSpPr>
+          <p:cNvPr id="37" name="Oval 36"/>
+          <p:cNvSpPr/>
+          <p:nvPr/>
+        </p:nvSpPr>
+        <p:spPr>
+          <a:xfrm>
+            <a:off x="8641080" y="2293315"/>
+            <a:ext cx="963777" cy="963777"/>
+          </a:xfrm>
+          <a:prstGeom prst="ellipse">
+            <a:avLst/>
+          </a:prstGeom>
+          <a:solidFill>
+            <a:srgbClr val="FFFFFF"/>
+          </a:solidFill>
+          <a:ln>
+            <a:noFill/>
+          </a:ln>
+          <a:effectLst/>
+        </p:spPr>
+        <p:style>
+          <a:lnRef idx="1">
+            <a:schemeClr val="accent1"/>
+          </a:lnRef>
+          <a:fillRef idx="3">
+            <a:schemeClr val="accent1"/>
+          </a:fillRef>
+          <a:effectRef idx="2">
+            <a:schemeClr val="accent1"/>
+          </a:effectRef>
+          <a:fontRef idx="minor">
+            <a:schemeClr val="lt1"/>
+          </a:fontRef>
+        </p:style>
+        <p:txBody>
+          <a:bodyPr rtlCol="0" anchor="ctr"/>
+          <a:lstStyle/>
+          <a:p>
+            <a:pPr algn="ctr"/>
+          </a:p>
+        </p:txBody>
+      </p:sp>
+      <p:sp>
+        <p:nvSpPr>
+          <p:cNvPr id="38" name="TextBox 37"/>
           <p:cNvSpPr txBox="1"/>
           <p:nvPr/>
         </p:nvSpPr>
         <p:spPr>
           <a:xfrm>
-            <a:off x="8414308" y="2011680"/>
-            <a:ext cx="2917850" cy="914400"/>
+            <a:off x="8414308" y="2048256"/>
+            <a:ext cx="1417320" cy="1417320"/>
           </a:xfrm>
           <a:prstGeom prst="rect">
             <a:avLst/>
@@ -21112,18 +22288,18 @@
           <a:noFill/>
         </p:spPr>
         <p:txBody>
-          <a:bodyPr wrap="square" anchor="t" lIns="0" rIns="0" tIns="0" bIns="0">
+          <a:bodyPr wrap="square" anchor="ctr" lIns="0" rIns="0" tIns="0" bIns="0">
             <a:spAutoFit/>
           </a:bodyPr>
           <a:lstStyle/>
           <a:p>
-            <a:pPr algn="l">
+            <a:pPr algn="ctr">
               <a:lnSpc>
                 <a:spcPct val="100000"/>
               </a:lnSpc>
             </a:pPr>
             <a:r>
-              <a:rPr sz="5000" b="1">
+              <a:rPr sz="2100" b="1">
                 <a:solidFill>
                   <a:srgbClr val="F5A623"/>
                 </a:solidFill>
@@ -21137,105 +22313,70 @@
       </p:sp>
       <p:sp>
         <p:nvSpPr>
-          <p:cNvPr id="32" name="Rounded Rectangle 31"/>
-          <p:cNvSpPr/>
-          <p:nvPr/>
-        </p:nvSpPr>
-        <p:spPr>
-          <a:xfrm>
-            <a:off x="8414308" y="3054096"/>
-            <a:ext cx="2917850" cy="128016"/>
-          </a:xfrm>
-          <a:prstGeom prst="roundRect">
-            <a:avLst>
-              <a:gd name="adj" fmla="val 50000"/>
-            </a:avLst>
-          </a:prstGeom>
-          <a:solidFill>
-            <a:srgbClr val="EAF0F6"/>
-          </a:solidFill>
-          <a:ln>
-            <a:noFill/>
-          </a:ln>
-          <a:effectLst/>
-        </p:spPr>
-        <p:style>
-          <a:lnRef idx="1">
-            <a:schemeClr val="accent1"/>
-          </a:lnRef>
-          <a:fillRef idx="3">
-            <a:schemeClr val="accent1"/>
-          </a:fillRef>
-          <a:effectRef idx="2">
-            <a:schemeClr val="accent1"/>
-          </a:effectRef>
-          <a:fontRef idx="minor">
-            <a:schemeClr val="lt1"/>
-          </a:fontRef>
-        </p:style>
-        <p:txBody>
-          <a:bodyPr rtlCol="0" anchor="ctr"/>
-          <a:lstStyle/>
-          <a:p>
-            <a:pPr algn="ctr"/>
-          </a:p>
-        </p:txBody>
-      </p:sp>
-      <p:sp>
-        <p:nvSpPr>
-          <p:cNvPr id="33" name="Rounded Rectangle 32"/>
-          <p:cNvSpPr/>
-          <p:nvPr/>
-        </p:nvSpPr>
-        <p:spPr>
-          <a:xfrm>
-            <a:off x="8414308" y="3054096"/>
-            <a:ext cx="583570" cy="128016"/>
-          </a:xfrm>
-          <a:prstGeom prst="roundRect">
-            <a:avLst>
-              <a:gd name="adj" fmla="val 50000"/>
-            </a:avLst>
-          </a:prstGeom>
-          <a:solidFill>
-            <a:srgbClr val="F5A623"/>
-          </a:solidFill>
-          <a:ln>
-            <a:noFill/>
-          </a:ln>
-          <a:effectLst/>
-        </p:spPr>
-        <p:style>
-          <a:lnRef idx="1">
-            <a:schemeClr val="accent1"/>
-          </a:lnRef>
-          <a:fillRef idx="3">
-            <a:schemeClr val="accent1"/>
-          </a:fillRef>
-          <a:effectRef idx="2">
-            <a:schemeClr val="accent1"/>
-          </a:effectRef>
-          <a:fontRef idx="minor">
-            <a:schemeClr val="lt1"/>
-          </a:fontRef>
-        </p:style>
-        <p:txBody>
-          <a:bodyPr rtlCol="0" anchor="ctr"/>
-          <a:lstStyle/>
-          <a:p>
-            <a:pPr algn="ctr"/>
-          </a:p>
-        </p:txBody>
-      </p:sp>
-      <p:sp>
-        <p:nvSpPr>
-          <p:cNvPr id="34" name="TextBox 33"/>
+          <p:cNvPr id="39" name="TextBox 38"/>
           <p:cNvSpPr txBox="1"/>
           <p:nvPr/>
         </p:nvSpPr>
         <p:spPr>
           <a:xfrm>
-            <a:off x="8414308" y="3364991"/>
+            <a:off x="10041940" y="2066544"/>
+            <a:ext cx="1354226" cy="1463040"/>
+          </a:xfrm>
+          <a:prstGeom prst="rect">
+            <a:avLst/>
+          </a:prstGeom>
+          <a:noFill/>
+        </p:spPr>
+        <p:txBody>
+          <a:bodyPr wrap="square" anchor="ctr" lIns="0" rIns="0" tIns="0" bIns="0">
+            <a:spAutoFit/>
+          </a:bodyPr>
+          <a:lstStyle/>
+          <a:p>
+            <a:pPr algn="l">
+              <a:lnSpc>
+                <a:spcPct val="115000"/>
+              </a:lnSpc>
+            </a:pPr>
+            <a:r>
+              <a:rPr sz="1200" b="0">
+                <a:solidFill>
+                  <a:srgbClr val="5B7083"/>
+                </a:solidFill>
+                <a:latin typeface="Calibri"/>
+                <a:ea typeface="Calibri"/>
+              </a:rPr>
+              <a:t>of tray</a:t>
+            </a:r>
+          </a:p>
+          <a:p>
+            <a:pPr algn="l">
+              <a:lnSpc>
+                <a:spcPct val="115000"/>
+              </a:lnSpc>
+            </a:pPr>
+            <a:r>
+              <a:rPr sz="1200" b="0">
+                <a:solidFill>
+                  <a:srgbClr val="5B7083"/>
+                </a:solidFill>
+                <a:latin typeface="Calibri"/>
+                <a:ea typeface="Calibri"/>
+              </a:rPr>
+              <a:t>cross-section</a:t>
+            </a:r>
+          </a:p>
+        </p:txBody>
+      </p:sp>
+      <p:sp>
+        <p:nvSpPr>
+          <p:cNvPr id="40" name="TextBox 39"/>
+          <p:cNvSpPr txBox="1"/>
+          <p:nvPr/>
+        </p:nvSpPr>
+        <p:spPr>
+          <a:xfrm>
+            <a:off x="8414308" y="3694176"/>
             <a:ext cx="2917850" cy="457200"/>
           </a:xfrm>
           <a:prstGeom prst="rect">
@@ -21269,14 +22410,14 @@
       </p:sp>
       <p:sp>
         <p:nvSpPr>
-          <p:cNvPr id="35" name="TextBox 34"/>
+          <p:cNvPr id="41" name="TextBox 40"/>
           <p:cNvSpPr txBox="1"/>
           <p:nvPr/>
         </p:nvSpPr>
         <p:spPr>
           <a:xfrm>
-            <a:off x="8414308" y="3803904"/>
-            <a:ext cx="2917850" cy="1280160"/>
+            <a:off x="8414308" y="4133088"/>
+            <a:ext cx="2917850" cy="1188720"/>
           </a:xfrm>
           <a:prstGeom prst="rect">
             <a:avLst/>
@@ -21886,7 +23027,13 @@
               <a:srgbClr val="D9E2EC"/>
             </a:solidFill>
           </a:ln>
-          <a:effectLst/>
+          <a:effectLst>
+            <a:outerShdw blurRad="140000" dist="50000" dir="5400000" rotWithShape="0">
+              <a:srgbClr val="16314E">
+                <a:alpha val="15000"/>
+              </a:srgbClr>
+            </a:outerShdw>
+          </a:effectLst>
         </p:spPr>
         <p:style>
           <a:lnRef idx="1">
@@ -22562,7 +23709,13 @@
               <a:srgbClr val="D9E2EC"/>
             </a:solidFill>
           </a:ln>
-          <a:effectLst/>
+          <a:effectLst>
+            <a:outerShdw blurRad="140000" dist="50000" dir="5400000" rotWithShape="0">
+              <a:srgbClr val="16314E">
+                <a:alpha val="15000"/>
+              </a:srgbClr>
+            </a:outerShdw>
+          </a:effectLst>
         </p:spPr>
         <p:style>
           <a:lnRef idx="1">
@@ -25666,7 +26819,13 @@
               <a:srgbClr val="D9E2EC"/>
             </a:solidFill>
           </a:ln>
-          <a:effectLst/>
+          <a:effectLst>
+            <a:outerShdw blurRad="140000" dist="50000" dir="5400000" rotWithShape="0">
+              <a:srgbClr val="16314E">
+                <a:alpha val="15000"/>
+              </a:srgbClr>
+            </a:outerShdw>
+          </a:effectLst>
         </p:spPr>
         <p:style>
           <a:lnRef idx="1">
@@ -25838,7 +26997,13 @@
               <a:srgbClr val="D9E2EC"/>
             </a:solidFill>
           </a:ln>
-          <a:effectLst/>
+          <a:effectLst>
+            <a:outerShdw blurRad="140000" dist="50000" dir="5400000" rotWithShape="0">
+              <a:srgbClr val="16314E">
+                <a:alpha val="15000"/>
+              </a:srgbClr>
+            </a:outerShdw>
+          </a:effectLst>
         </p:spPr>
         <p:style>
           <a:lnRef idx="1">
@@ -26010,7 +27175,13 @@
               <a:srgbClr val="D9E2EC"/>
             </a:solidFill>
           </a:ln>
-          <a:effectLst/>
+          <a:effectLst>
+            <a:outerShdw blurRad="140000" dist="50000" dir="5400000" rotWithShape="0">
+              <a:srgbClr val="16314E">
+                <a:alpha val="15000"/>
+              </a:srgbClr>
+            </a:outerShdw>
+          </a:effectLst>
         </p:spPr>
         <p:style>
           <a:lnRef idx="1">
@@ -26737,7 +27908,13 @@
               <a:srgbClr val="D9E2EC"/>
             </a:solidFill>
           </a:ln>
-          <a:effectLst/>
+          <a:effectLst>
+            <a:outerShdw blurRad="140000" dist="50000" dir="5400000" rotWithShape="0">
+              <a:srgbClr val="16314E">
+                <a:alpha val="15000"/>
+              </a:srgbClr>
+            </a:outerShdw>
+          </a:effectLst>
         </p:spPr>
         <p:style>
           <a:lnRef idx="1">
@@ -26909,7 +28086,13 @@
               <a:srgbClr val="D9E2EC"/>
             </a:solidFill>
           </a:ln>
-          <a:effectLst/>
+          <a:effectLst>
+            <a:outerShdw blurRad="140000" dist="50000" dir="5400000" rotWithShape="0">
+              <a:srgbClr val="16314E">
+                <a:alpha val="15000"/>
+              </a:srgbClr>
+            </a:outerShdw>
+          </a:effectLst>
         </p:spPr>
         <p:style>
           <a:lnRef idx="1">
@@ -27081,7 +28264,13 @@
               <a:srgbClr val="D9E2EC"/>
             </a:solidFill>
           </a:ln>
-          <a:effectLst/>
+          <a:effectLst>
+            <a:outerShdw blurRad="140000" dist="50000" dir="5400000" rotWithShape="0">
+              <a:srgbClr val="16314E">
+                <a:alpha val="15000"/>
+              </a:srgbClr>
+            </a:outerShdw>
+          </a:effectLst>
         </p:spPr>
         <p:style>
           <a:lnRef idx="1">
@@ -28445,7 +29634,13 @@
               <a:srgbClr val="D9E2EC"/>
             </a:solidFill>
           </a:ln>
-          <a:effectLst/>
+          <a:effectLst>
+            <a:outerShdw blurRad="140000" dist="50000" dir="5400000" rotWithShape="0">
+              <a:srgbClr val="16314E">
+                <a:alpha val="15000"/>
+              </a:srgbClr>
+            </a:outerShdw>
+          </a:effectLst>
         </p:spPr>
         <p:style>
           <a:lnRef idx="1">
@@ -28603,13 +29798,104 @@
       </p:sp>
       <p:sp>
         <p:nvSpPr>
-          <p:cNvPr id="19" name="TextBox 18"/>
+          <p:cNvPr id="19" name="Arc 18"/>
+          <p:cNvSpPr/>
+          <p:nvPr/>
+        </p:nvSpPr>
+        <p:spPr>
+          <a:xfrm>
+            <a:off x="2641015" y="1993392"/>
+            <a:ext cx="274320" cy="274320"/>
+          </a:xfrm>
+          <a:prstGeom prst="arc">
+            <a:avLst>
+              <a:gd name="adj1" fmla="val 10800000"/>
+              <a:gd name="adj2" fmla="val 16200000"/>
+            </a:avLst>
+          </a:prstGeom>
+          <a:noFill/>
+          <a:ln w="38100">
+            <a:solidFill>
+              <a:srgbClr val="36A9E0"/>
+            </a:solidFill>
+          </a:ln>
+          <a:effectLst/>
+        </p:spPr>
+        <p:style>
+          <a:lnRef idx="1">
+            <a:schemeClr val="accent1"/>
+          </a:lnRef>
+          <a:fillRef idx="3">
+            <a:schemeClr val="accent1"/>
+          </a:fillRef>
+          <a:effectRef idx="2">
+            <a:schemeClr val="accent1"/>
+          </a:effectRef>
+          <a:fontRef idx="minor">
+            <a:schemeClr val="lt1"/>
+          </a:fontRef>
+        </p:style>
+        <p:txBody>
+          <a:bodyPr rtlCol="0" anchor="ctr"/>
+          <a:lstStyle/>
+          <a:p>
+            <a:pPr algn="ctr"/>
+          </a:p>
+        </p:txBody>
+      </p:sp>
+      <p:sp>
+        <p:nvSpPr>
+          <p:cNvPr id="20" name="Oval 19"/>
+          <p:cNvSpPr/>
+          <p:nvPr/>
+        </p:nvSpPr>
+        <p:spPr>
+          <a:xfrm>
+            <a:off x="2595295" y="2221992"/>
+            <a:ext cx="100584" cy="100584"/>
+          </a:xfrm>
+          <a:prstGeom prst="ellipse">
+            <a:avLst/>
+          </a:prstGeom>
+          <a:solidFill>
+            <a:srgbClr val="36A9E0"/>
+          </a:solidFill>
+          <a:ln>
+            <a:noFill/>
+          </a:ln>
+          <a:effectLst/>
+        </p:spPr>
+        <p:style>
+          <a:lnRef idx="1">
+            <a:schemeClr val="accent1"/>
+          </a:lnRef>
+          <a:fillRef idx="3">
+            <a:schemeClr val="accent1"/>
+          </a:fillRef>
+          <a:effectRef idx="2">
+            <a:schemeClr val="accent1"/>
+          </a:effectRef>
+          <a:fontRef idx="minor">
+            <a:schemeClr val="lt1"/>
+          </a:fontRef>
+        </p:style>
+        <p:txBody>
+          <a:bodyPr rtlCol="0" anchor="ctr"/>
+          <a:lstStyle/>
+          <a:p>
+            <a:pPr algn="ctr"/>
+          </a:p>
+        </p:txBody>
+      </p:sp>
+      <p:sp>
+        <p:nvSpPr>
+          <p:cNvPr id="21" name="TextBox 20"/>
           <p:cNvSpPr txBox="1"/>
           <p:nvPr/>
         </p:nvSpPr>
         <p:spPr>
           <a:xfrm>
-            <a:off x="822960" y="2505456"/>
+            <a:off x="822960" y="2688336"/>
             <a:ext cx="2074087" cy="868680"/>
           </a:xfrm>
           <a:prstGeom prst="rect">
@@ -28643,13 +29929,13 @@
       </p:sp>
       <p:sp>
         <p:nvSpPr>
-          <p:cNvPr id="20" name="TextBox 19"/>
+          <p:cNvPr id="22" name="TextBox 21"/>
           <p:cNvSpPr txBox="1"/>
           <p:nvPr/>
         </p:nvSpPr>
         <p:spPr>
           <a:xfrm>
-            <a:off x="822960" y="3383280"/>
+            <a:off x="822960" y="3529584"/>
             <a:ext cx="2074087" cy="411480"/>
           </a:xfrm>
           <a:prstGeom prst="rect">
@@ -28683,13 +29969,13 @@
       </p:sp>
       <p:cxnSp>
         <p:nvCxnSpPr>
-          <p:cNvPr id="21" name="Connector 20"/>
+          <p:cNvPr id="23" name="Connector 22"/>
           <p:cNvCxnSpPr/>
           <p:nvPr/>
         </p:nvCxnSpPr>
         <p:spPr>
           <a:xfrm>
-            <a:off x="822960" y="3877056"/>
+            <a:off x="822960" y="3986784"/>
             <a:ext cx="2074087" cy="0"/>
           </a:xfrm>
           <a:prstGeom prst="line">
@@ -28719,14 +30005,14 @@
       </p:cxnSp>
       <p:sp>
         <p:nvSpPr>
-          <p:cNvPr id="22" name="TextBox 21"/>
+          <p:cNvPr id="24" name="TextBox 23"/>
           <p:cNvSpPr txBox="1"/>
           <p:nvPr/>
         </p:nvSpPr>
         <p:spPr>
           <a:xfrm>
-            <a:off x="822960" y="4005072"/>
-            <a:ext cx="2074087" cy="1280160"/>
+            <a:off x="822960" y="4114800"/>
+            <a:ext cx="2074087" cy="1188720"/>
           </a:xfrm>
           <a:prstGeom prst="rect">
             <a:avLst/>
@@ -28759,7 +30045,7 @@
       </p:sp>
       <p:sp>
         <p:nvSpPr>
-          <p:cNvPr id="23" name="Rounded Rectangle 22"/>
+          <p:cNvPr id="25" name="Rounded Rectangle 24"/>
           <p:cNvSpPr/>
           <p:nvPr/>
         </p:nvSpPr>
@@ -28781,7 +30067,13 @@
               <a:srgbClr val="D9E2EC"/>
             </a:solidFill>
           </a:ln>
-          <a:effectLst/>
+          <a:effectLst>
+            <a:outerShdw blurRad="140000" dist="50000" dir="5400000" rotWithShape="0">
+              <a:srgbClr val="16314E">
+                <a:alpha val="15000"/>
+              </a:srgbClr>
+            </a:outerShdw>
+          </a:effectLst>
         </p:spPr>
         <p:style>
           <a:lnRef idx="1">
@@ -28807,7 +30099,7 @@
       </p:sp>
       <p:sp>
         <p:nvSpPr>
-          <p:cNvPr id="24" name="Rectangle 23"/>
+          <p:cNvPr id="26" name="Rectangle 25"/>
           <p:cNvSpPr/>
           <p:nvPr/>
         </p:nvSpPr>
@@ -28851,7 +30143,7 @@
       </p:sp>
       <p:sp>
         <p:nvSpPr>
-          <p:cNvPr id="25" name="Rounded Rectangle 24"/>
+          <p:cNvPr id="27" name="Rounded Rectangle 26"/>
           <p:cNvSpPr/>
           <p:nvPr/>
         </p:nvSpPr>
@@ -28899,7 +30191,7 @@
       </p:sp>
       <p:sp>
         <p:nvSpPr>
-          <p:cNvPr id="26" name="TextBox 25"/>
+          <p:cNvPr id="28" name="TextBox 27"/>
           <p:cNvSpPr txBox="1"/>
           <p:nvPr/>
         </p:nvSpPr>
@@ -28939,13 +30231,104 @@
       </p:sp>
       <p:sp>
         <p:nvSpPr>
-          <p:cNvPr id="27" name="TextBox 26"/>
+          <p:cNvPr id="29" name="Arc 28"/>
+          <p:cNvSpPr/>
+          <p:nvPr/>
+        </p:nvSpPr>
+        <p:spPr>
+          <a:xfrm>
+            <a:off x="5373471" y="1993392"/>
+            <a:ext cx="365760" cy="365760"/>
+          </a:xfrm>
+          <a:prstGeom prst="arc">
+            <a:avLst>
+              <a:gd name="adj1" fmla="val 10800000"/>
+              <a:gd name="adj2" fmla="val 16200000"/>
+            </a:avLst>
+          </a:prstGeom>
+          <a:noFill/>
+          <a:ln w="38100">
+            <a:solidFill>
+              <a:srgbClr val="1F6FB2"/>
+            </a:solidFill>
+          </a:ln>
+          <a:effectLst/>
+        </p:spPr>
+        <p:style>
+          <a:lnRef idx="1">
+            <a:schemeClr val="accent1"/>
+          </a:lnRef>
+          <a:fillRef idx="3">
+            <a:schemeClr val="accent1"/>
+          </a:fillRef>
+          <a:effectRef idx="2">
+            <a:schemeClr val="accent1"/>
+          </a:effectRef>
+          <a:fontRef idx="minor">
+            <a:schemeClr val="lt1"/>
+          </a:fontRef>
+        </p:style>
+        <p:txBody>
+          <a:bodyPr rtlCol="0" anchor="ctr"/>
+          <a:lstStyle/>
+          <a:p>
+            <a:pPr algn="ctr"/>
+          </a:p>
+        </p:txBody>
+      </p:sp>
+      <p:sp>
+        <p:nvSpPr>
+          <p:cNvPr id="30" name="Oval 29"/>
+          <p:cNvSpPr/>
+          <p:nvPr/>
+        </p:nvSpPr>
+        <p:spPr>
+          <a:xfrm>
+            <a:off x="5327751" y="2313432"/>
+            <a:ext cx="100584" cy="100584"/>
+          </a:xfrm>
+          <a:prstGeom prst="ellipse">
+            <a:avLst/>
+          </a:prstGeom>
+          <a:solidFill>
+            <a:srgbClr val="1F6FB2"/>
+          </a:solidFill>
+          <a:ln>
+            <a:noFill/>
+          </a:ln>
+          <a:effectLst/>
+        </p:spPr>
+        <p:style>
+          <a:lnRef idx="1">
+            <a:schemeClr val="accent1"/>
+          </a:lnRef>
+          <a:fillRef idx="3">
+            <a:schemeClr val="accent1"/>
+          </a:fillRef>
+          <a:effectRef idx="2">
+            <a:schemeClr val="accent1"/>
+          </a:effectRef>
+          <a:fontRef idx="minor">
+            <a:schemeClr val="lt1"/>
+          </a:fontRef>
+        </p:style>
+        <p:txBody>
+          <a:bodyPr rtlCol="0" anchor="ctr"/>
+          <a:lstStyle/>
+          <a:p>
+            <a:pPr algn="ctr"/>
+          </a:p>
+        </p:txBody>
+      </p:sp>
+      <p:sp>
+        <p:nvSpPr>
+          <p:cNvPr id="31" name="TextBox 30"/>
           <p:cNvSpPr txBox="1"/>
           <p:nvPr/>
         </p:nvSpPr>
         <p:spPr>
           <a:xfrm>
-            <a:off x="3646855" y="2505456"/>
+            <a:off x="3646855" y="2688336"/>
             <a:ext cx="2074087" cy="868680"/>
           </a:xfrm>
           <a:prstGeom prst="rect">
@@ -28979,13 +30362,13 @@
       </p:sp>
       <p:sp>
         <p:nvSpPr>
-          <p:cNvPr id="28" name="TextBox 27"/>
+          <p:cNvPr id="32" name="TextBox 31"/>
           <p:cNvSpPr txBox="1"/>
           <p:nvPr/>
         </p:nvSpPr>
         <p:spPr>
           <a:xfrm>
-            <a:off x="3646855" y="3383280"/>
+            <a:off x="3646855" y="3529584"/>
             <a:ext cx="2074087" cy="411480"/>
           </a:xfrm>
           <a:prstGeom prst="rect">
@@ -29019,13 +30402,13 @@
       </p:sp>
       <p:cxnSp>
         <p:nvCxnSpPr>
-          <p:cNvPr id="29" name="Connector 28"/>
+          <p:cNvPr id="33" name="Connector 32"/>
           <p:cNvCxnSpPr/>
           <p:nvPr/>
         </p:nvCxnSpPr>
         <p:spPr>
           <a:xfrm>
-            <a:off x="3646855" y="3877056"/>
+            <a:off x="3646855" y="3986784"/>
             <a:ext cx="2074088" cy="0"/>
           </a:xfrm>
           <a:prstGeom prst="line">
@@ -29055,14 +30438,14 @@
       </p:cxnSp>
       <p:sp>
         <p:nvSpPr>
-          <p:cNvPr id="30" name="TextBox 29"/>
+          <p:cNvPr id="34" name="TextBox 33"/>
           <p:cNvSpPr txBox="1"/>
           <p:nvPr/>
         </p:nvSpPr>
         <p:spPr>
           <a:xfrm>
-            <a:off x="3646855" y="4005072"/>
-            <a:ext cx="2074087" cy="1280160"/>
+            <a:off x="3646855" y="4114800"/>
+            <a:ext cx="2074087" cy="1188720"/>
           </a:xfrm>
           <a:prstGeom prst="rect">
             <a:avLst/>
@@ -29095,7 +30478,7 @@
       </p:sp>
       <p:sp>
         <p:nvSpPr>
-          <p:cNvPr id="31" name="Rounded Rectangle 30"/>
+          <p:cNvPr id="35" name="Rounded Rectangle 34"/>
           <p:cNvSpPr/>
           <p:nvPr/>
         </p:nvSpPr>
@@ -29117,7 +30500,13 @@
               <a:srgbClr val="D9E2EC"/>
             </a:solidFill>
           </a:ln>
-          <a:effectLst/>
+          <a:effectLst>
+            <a:outerShdw blurRad="140000" dist="50000" dir="5400000" rotWithShape="0">
+              <a:srgbClr val="16314E">
+                <a:alpha val="15000"/>
+              </a:srgbClr>
+            </a:outerShdw>
+          </a:effectLst>
         </p:spPr>
         <p:style>
           <a:lnRef idx="1">
@@ -29143,7 +30532,7 @@
       </p:sp>
       <p:sp>
         <p:nvSpPr>
-          <p:cNvPr id="32" name="Rectangle 31"/>
+          <p:cNvPr id="36" name="Rectangle 35"/>
           <p:cNvSpPr/>
           <p:nvPr/>
         </p:nvSpPr>
@@ -29187,7 +30576,7 @@
       </p:sp>
       <p:sp>
         <p:nvSpPr>
-          <p:cNvPr id="33" name="Rounded Rectangle 32"/>
+          <p:cNvPr id="37" name="Rounded Rectangle 36"/>
           <p:cNvSpPr/>
           <p:nvPr/>
         </p:nvSpPr>
@@ -29235,7 +30624,7 @@
       </p:sp>
       <p:sp>
         <p:nvSpPr>
-          <p:cNvPr id="34" name="TextBox 33"/>
+          <p:cNvPr id="38" name="TextBox 37"/>
           <p:cNvSpPr txBox="1"/>
           <p:nvPr/>
         </p:nvSpPr>
@@ -29275,13 +30664,104 @@
       </p:sp>
       <p:sp>
         <p:nvSpPr>
-          <p:cNvPr id="35" name="TextBox 34"/>
+          <p:cNvPr id="39" name="Arc 38"/>
+          <p:cNvSpPr/>
+          <p:nvPr/>
+        </p:nvSpPr>
+        <p:spPr>
+          <a:xfrm>
+            <a:off x="8105927" y="1993392"/>
+            <a:ext cx="457200" cy="457200"/>
+          </a:xfrm>
+          <a:prstGeom prst="arc">
+            <a:avLst>
+              <a:gd name="adj1" fmla="val 10800000"/>
+              <a:gd name="adj2" fmla="val 16200000"/>
+            </a:avLst>
+          </a:prstGeom>
+          <a:noFill/>
+          <a:ln w="38100">
+            <a:solidFill>
+              <a:srgbClr val="0F2B46"/>
+            </a:solidFill>
+          </a:ln>
+          <a:effectLst/>
+        </p:spPr>
+        <p:style>
+          <a:lnRef idx="1">
+            <a:schemeClr val="accent1"/>
+          </a:lnRef>
+          <a:fillRef idx="3">
+            <a:schemeClr val="accent1"/>
+          </a:fillRef>
+          <a:effectRef idx="2">
+            <a:schemeClr val="accent1"/>
+          </a:effectRef>
+          <a:fontRef idx="minor">
+            <a:schemeClr val="lt1"/>
+          </a:fontRef>
+        </p:style>
+        <p:txBody>
+          <a:bodyPr rtlCol="0" anchor="ctr"/>
+          <a:lstStyle/>
+          <a:p>
+            <a:pPr algn="ctr"/>
+          </a:p>
+        </p:txBody>
+      </p:sp>
+      <p:sp>
+        <p:nvSpPr>
+          <p:cNvPr id="40" name="Oval 39"/>
+          <p:cNvSpPr/>
+          <p:nvPr/>
+        </p:nvSpPr>
+        <p:spPr>
+          <a:xfrm>
+            <a:off x="8060207" y="2404872"/>
+            <a:ext cx="100584" cy="100584"/>
+          </a:xfrm>
+          <a:prstGeom prst="ellipse">
+            <a:avLst/>
+          </a:prstGeom>
+          <a:solidFill>
+            <a:srgbClr val="0F2B46"/>
+          </a:solidFill>
+          <a:ln>
+            <a:noFill/>
+          </a:ln>
+          <a:effectLst/>
+        </p:spPr>
+        <p:style>
+          <a:lnRef idx="1">
+            <a:schemeClr val="accent1"/>
+          </a:lnRef>
+          <a:fillRef idx="3">
+            <a:schemeClr val="accent1"/>
+          </a:fillRef>
+          <a:effectRef idx="2">
+            <a:schemeClr val="accent1"/>
+          </a:effectRef>
+          <a:fontRef idx="minor">
+            <a:schemeClr val="lt1"/>
+          </a:fontRef>
+        </p:style>
+        <p:txBody>
+          <a:bodyPr rtlCol="0" anchor="ctr"/>
+          <a:lstStyle/>
+          <a:p>
+            <a:pPr algn="ctr"/>
+          </a:p>
+        </p:txBody>
+      </p:sp>
+      <p:sp>
+        <p:nvSpPr>
+          <p:cNvPr id="41" name="TextBox 40"/>
           <p:cNvSpPr txBox="1"/>
           <p:nvPr/>
         </p:nvSpPr>
         <p:spPr>
           <a:xfrm>
-            <a:off x="6470751" y="2505456"/>
+            <a:off x="6470751" y="2688336"/>
             <a:ext cx="2074087" cy="868680"/>
           </a:xfrm>
           <a:prstGeom prst="rect">
@@ -29315,13 +30795,13 @@
       </p:sp>
       <p:sp>
         <p:nvSpPr>
-          <p:cNvPr id="36" name="TextBox 35"/>
+          <p:cNvPr id="42" name="TextBox 41"/>
           <p:cNvSpPr txBox="1"/>
           <p:nvPr/>
         </p:nvSpPr>
         <p:spPr>
           <a:xfrm>
-            <a:off x="6470751" y="3383280"/>
+            <a:off x="6470751" y="3529584"/>
             <a:ext cx="2074087" cy="411480"/>
           </a:xfrm>
           <a:prstGeom prst="rect">
@@ -29355,13 +30835,13 @@
       </p:sp>
       <p:cxnSp>
         <p:nvCxnSpPr>
-          <p:cNvPr id="37" name="Connector 36"/>
+          <p:cNvPr id="43" name="Connector 42"/>
           <p:cNvCxnSpPr/>
           <p:nvPr/>
         </p:nvCxnSpPr>
         <p:spPr>
           <a:xfrm>
-            <a:off x="6470751" y="3877056"/>
+            <a:off x="6470751" y="3986784"/>
             <a:ext cx="2074088" cy="0"/>
           </a:xfrm>
           <a:prstGeom prst="line">
@@ -29391,14 +30871,14 @@
       </p:cxnSp>
       <p:sp>
         <p:nvSpPr>
-          <p:cNvPr id="38" name="TextBox 37"/>
+          <p:cNvPr id="44" name="TextBox 43"/>
           <p:cNvSpPr txBox="1"/>
           <p:nvPr/>
         </p:nvSpPr>
         <p:spPr>
           <a:xfrm>
-            <a:off x="6470751" y="4005072"/>
-            <a:ext cx="2074087" cy="1280160"/>
+            <a:off x="6470751" y="4114800"/>
+            <a:ext cx="2074087" cy="1188720"/>
           </a:xfrm>
           <a:prstGeom prst="rect">
             <a:avLst/>
@@ -29431,7 +30911,7 @@
       </p:sp>
       <p:sp>
         <p:nvSpPr>
-          <p:cNvPr id="39" name="Rounded Rectangle 38"/>
+          <p:cNvPr id="45" name="Rounded Rectangle 44"/>
           <p:cNvSpPr/>
           <p:nvPr/>
         </p:nvSpPr>
@@ -29453,7 +30933,13 @@
               <a:srgbClr val="D9E2EC"/>
             </a:solidFill>
           </a:ln>
-          <a:effectLst/>
+          <a:effectLst>
+            <a:outerShdw blurRad="140000" dist="50000" dir="5400000" rotWithShape="0">
+              <a:srgbClr val="16314E">
+                <a:alpha val="15000"/>
+              </a:srgbClr>
+            </a:outerShdw>
+          </a:effectLst>
         </p:spPr>
         <p:style>
           <a:lnRef idx="1">
@@ -29479,7 +30965,7 @@
       </p:sp>
       <p:sp>
         <p:nvSpPr>
-          <p:cNvPr id="40" name="Rectangle 39"/>
+          <p:cNvPr id="46" name="Rectangle 45"/>
           <p:cNvSpPr/>
           <p:nvPr/>
         </p:nvSpPr>
@@ -29523,7 +31009,7 @@
       </p:sp>
       <p:sp>
         <p:nvSpPr>
-          <p:cNvPr id="41" name="Rounded Rectangle 40"/>
+          <p:cNvPr id="47" name="Rounded Rectangle 46"/>
           <p:cNvSpPr/>
           <p:nvPr/>
         </p:nvSpPr>
@@ -29571,7 +31057,7 @@
       </p:sp>
       <p:sp>
         <p:nvSpPr>
-          <p:cNvPr id="42" name="TextBox 41"/>
+          <p:cNvPr id="48" name="TextBox 47"/>
           <p:cNvSpPr txBox="1"/>
           <p:nvPr/>
         </p:nvSpPr>
@@ -29611,13 +31097,104 @@
       </p:sp>
       <p:sp>
         <p:nvSpPr>
-          <p:cNvPr id="43" name="TextBox 42"/>
+          <p:cNvPr id="49" name="Arc 48"/>
+          <p:cNvSpPr/>
+          <p:nvPr/>
+        </p:nvSpPr>
+        <p:spPr>
+          <a:xfrm>
+            <a:off x="10838383" y="1993392"/>
+            <a:ext cx="548640" cy="548640"/>
+          </a:xfrm>
+          <a:prstGeom prst="arc">
+            <a:avLst>
+              <a:gd name="adj1" fmla="val 10800000"/>
+              <a:gd name="adj2" fmla="val 16200000"/>
+            </a:avLst>
+          </a:prstGeom>
+          <a:noFill/>
+          <a:ln w="38100">
+            <a:solidFill>
+              <a:srgbClr val="F5A623"/>
+            </a:solidFill>
+          </a:ln>
+          <a:effectLst/>
+        </p:spPr>
+        <p:style>
+          <a:lnRef idx="1">
+            <a:schemeClr val="accent1"/>
+          </a:lnRef>
+          <a:fillRef idx="3">
+            <a:schemeClr val="accent1"/>
+          </a:fillRef>
+          <a:effectRef idx="2">
+            <a:schemeClr val="accent1"/>
+          </a:effectRef>
+          <a:fontRef idx="minor">
+            <a:schemeClr val="lt1"/>
+          </a:fontRef>
+        </p:style>
+        <p:txBody>
+          <a:bodyPr rtlCol="0" anchor="ctr"/>
+          <a:lstStyle/>
+          <a:p>
+            <a:pPr algn="ctr"/>
+          </a:p>
+        </p:txBody>
+      </p:sp>
+      <p:sp>
+        <p:nvSpPr>
+          <p:cNvPr id="50" name="Oval 49"/>
+          <p:cNvSpPr/>
+          <p:nvPr/>
+        </p:nvSpPr>
+        <p:spPr>
+          <a:xfrm>
+            <a:off x="10792663" y="2496312"/>
+            <a:ext cx="100584" cy="100584"/>
+          </a:xfrm>
+          <a:prstGeom prst="ellipse">
+            <a:avLst/>
+          </a:prstGeom>
+          <a:solidFill>
+            <a:srgbClr val="F5A623"/>
+          </a:solidFill>
+          <a:ln>
+            <a:noFill/>
+          </a:ln>
+          <a:effectLst/>
+        </p:spPr>
+        <p:style>
+          <a:lnRef idx="1">
+            <a:schemeClr val="accent1"/>
+          </a:lnRef>
+          <a:fillRef idx="3">
+            <a:schemeClr val="accent1"/>
+          </a:fillRef>
+          <a:effectRef idx="2">
+            <a:schemeClr val="accent1"/>
+          </a:effectRef>
+          <a:fontRef idx="minor">
+            <a:schemeClr val="lt1"/>
+          </a:fontRef>
+        </p:style>
+        <p:txBody>
+          <a:bodyPr rtlCol="0" anchor="ctr"/>
+          <a:lstStyle/>
+          <a:p>
+            <a:pPr algn="ctr"/>
+          </a:p>
+        </p:txBody>
+      </p:sp>
+      <p:sp>
+        <p:nvSpPr>
+          <p:cNvPr id="51" name="TextBox 50"/>
           <p:cNvSpPr txBox="1"/>
           <p:nvPr/>
         </p:nvSpPr>
         <p:spPr>
           <a:xfrm>
-            <a:off x="9294647" y="2505456"/>
+            <a:off x="9294647" y="2688336"/>
             <a:ext cx="2074087" cy="868680"/>
           </a:xfrm>
           <a:prstGeom prst="rect">
@@ -29651,13 +31228,13 @@
       </p:sp>
       <p:sp>
         <p:nvSpPr>
-          <p:cNvPr id="44" name="TextBox 43"/>
+          <p:cNvPr id="52" name="TextBox 51"/>
           <p:cNvSpPr txBox="1"/>
           <p:nvPr/>
         </p:nvSpPr>
         <p:spPr>
           <a:xfrm>
-            <a:off x="9294647" y="3383280"/>
+            <a:off x="9294647" y="3529584"/>
             <a:ext cx="2074087" cy="411480"/>
           </a:xfrm>
           <a:prstGeom prst="rect">
@@ -29691,13 +31268,13 @@
       </p:sp>
       <p:cxnSp>
         <p:nvCxnSpPr>
-          <p:cNvPr id="45" name="Connector 44"/>
+          <p:cNvPr id="53" name="Connector 52"/>
           <p:cNvCxnSpPr/>
           <p:nvPr/>
         </p:nvCxnSpPr>
         <p:spPr>
           <a:xfrm>
-            <a:off x="9294647" y="3877056"/>
+            <a:off x="9294647" y="3986784"/>
             <a:ext cx="2074088" cy="0"/>
           </a:xfrm>
           <a:prstGeom prst="line">
@@ -29727,14 +31304,14 @@
       </p:cxnSp>
       <p:sp>
         <p:nvSpPr>
-          <p:cNvPr id="46" name="TextBox 45"/>
+          <p:cNvPr id="54" name="TextBox 53"/>
           <p:cNvSpPr txBox="1"/>
           <p:nvPr/>
         </p:nvSpPr>
         <p:spPr>
           <a:xfrm>
-            <a:off x="9294647" y="4005072"/>
-            <a:ext cx="2074087" cy="1280160"/>
+            <a:off x="9294647" y="4114800"/>
+            <a:ext cx="2074087" cy="1188720"/>
           </a:xfrm>
           <a:prstGeom prst="rect">
             <a:avLst/>

</xml_diff>